<commit_message>
docs: add documentation for GZIP and GUNZIP functions
</commit_message>
<xml_diff>
--- a/Db2 Routines Presentation.pptx
+++ b/Db2 Routines Presentation.pptx
@@ -591,7 +591,7 @@
           </a:ln>
           <a:extLst>
             <a:ext uri="{C572A759-6A51-4108-AA02-DFA0A04FC94B}">
-              <ma14:wrappingTextBoxFlag xmlns:ma14="http://schemas.microsoft.com/office/mac/drawingml/2011/main" xmlns:a14="http://schemas.microsoft.com/office/drawing/2010/main" xmlns:m="http://schemas.openxmlformats.org/officeDocument/2006/math" xmlns="" val="1"/>
+              <ma14:wrappingTextBoxFlag xmlns="" xmlns:m="http://schemas.openxmlformats.org/officeDocument/2006/math" xmlns:a14="http://schemas.microsoft.com/office/drawing/2010/main" xmlns:ma14="http://schemas.microsoft.com/office/mac/drawingml/2011/main" val="1"/>
             </a:ext>
           </a:extLst>
         </p:spPr>
@@ -1702,7 +1702,7 @@
           </a:ln>
           <a:extLst>
             <a:ext uri="{C572A759-6A51-4108-AA02-DFA0A04FC94B}">
-              <ma14:wrappingTextBoxFlag xmlns:ma14="http://schemas.microsoft.com/office/mac/drawingml/2011/main" xmlns:a14="http://schemas.microsoft.com/office/drawing/2010/main" xmlns:m="http://schemas.openxmlformats.org/officeDocument/2006/math" xmlns="" val="1"/>
+              <ma14:wrappingTextBoxFlag xmlns="" xmlns:m="http://schemas.openxmlformats.org/officeDocument/2006/math" xmlns:a14="http://schemas.microsoft.com/office/drawing/2010/main" xmlns:ma14="http://schemas.microsoft.com/office/mac/drawingml/2011/main" val="1"/>
             </a:ext>
           </a:extLst>
         </p:spPr>
@@ -1844,7 +1844,7 @@
           </a:ln>
           <a:extLst>
             <a:ext uri="{C572A759-6A51-4108-AA02-DFA0A04FC94B}">
-              <ma14:wrappingTextBoxFlag xmlns:ma14="http://schemas.microsoft.com/office/mac/drawingml/2011/main" xmlns:a14="http://schemas.microsoft.com/office/drawing/2010/main" xmlns:m="http://schemas.openxmlformats.org/officeDocument/2006/math" xmlns="" val="1"/>
+              <ma14:wrappingTextBoxFlag xmlns="" xmlns:m="http://schemas.openxmlformats.org/officeDocument/2006/math" xmlns:a14="http://schemas.microsoft.com/office/drawing/2010/main" xmlns:ma14="http://schemas.microsoft.com/office/mac/drawingml/2011/main" val="1"/>
             </a:ext>
           </a:extLst>
         </p:spPr>
@@ -2334,7 +2334,7 @@
           </a:ln>
           <a:extLst>
             <a:ext uri="{C572A759-6A51-4108-AA02-DFA0A04FC94B}">
-              <ma14:wrappingTextBoxFlag xmlns:ma14="http://schemas.microsoft.com/office/mac/drawingml/2011/main" xmlns:a14="http://schemas.microsoft.com/office/drawing/2010/main" xmlns:m="http://schemas.openxmlformats.org/officeDocument/2006/math" xmlns="" val="1"/>
+              <ma14:wrappingTextBoxFlag xmlns="" xmlns:m="http://schemas.openxmlformats.org/officeDocument/2006/math" xmlns:a14="http://schemas.microsoft.com/office/drawing/2010/main" xmlns:ma14="http://schemas.microsoft.com/office/mac/drawingml/2011/main" val="1"/>
             </a:ext>
           </a:extLst>
         </p:spPr>
@@ -2716,7 +2716,7 @@
           </a:ln>
           <a:extLst>
             <a:ext uri="{C572A759-6A51-4108-AA02-DFA0A04FC94B}">
-              <ma14:wrappingTextBoxFlag xmlns:ma14="http://schemas.microsoft.com/office/mac/drawingml/2011/main" xmlns:a14="http://schemas.microsoft.com/office/drawing/2010/main" xmlns:m="http://schemas.openxmlformats.org/officeDocument/2006/math" xmlns="" val="1"/>
+              <ma14:wrappingTextBoxFlag xmlns="" xmlns:m="http://schemas.openxmlformats.org/officeDocument/2006/math" xmlns:a14="http://schemas.microsoft.com/office/drawing/2010/main" xmlns:ma14="http://schemas.microsoft.com/office/mac/drawingml/2011/main" val="1"/>
             </a:ext>
           </a:extLst>
         </p:spPr>
@@ -4326,7 +4326,7 @@
           </a:ln>
           <a:extLst>
             <a:ext uri="{C572A759-6A51-4108-AA02-DFA0A04FC94B}">
-              <ma14:wrappingTextBoxFlag xmlns:ma14="http://schemas.microsoft.com/office/mac/drawingml/2011/main" xmlns:a14="http://schemas.microsoft.com/office/drawing/2010/main" xmlns:m="http://schemas.openxmlformats.org/officeDocument/2006/math" xmlns="" val="1"/>
+              <ma14:wrappingTextBoxFlag xmlns="" xmlns:m="http://schemas.openxmlformats.org/officeDocument/2006/math" xmlns:a14="http://schemas.microsoft.com/office/drawing/2010/main" xmlns:ma14="http://schemas.microsoft.com/office/mac/drawingml/2011/main" val="1"/>
             </a:ext>
           </a:extLst>
         </p:spPr>
@@ -7618,7 +7618,7 @@
           </a:ln>
           <a:extLst>
             <a:ext uri="{C572A759-6A51-4108-AA02-DFA0A04FC94B}">
-              <ma14:wrappingTextBoxFlag xmlns:ma14="http://schemas.microsoft.com/office/mac/drawingml/2011/main" xmlns:a14="http://schemas.microsoft.com/office/drawing/2010/main" xmlns:m="http://schemas.openxmlformats.org/officeDocument/2006/math" xmlns="" val="1"/>
+              <ma14:wrappingTextBoxFlag xmlns="" xmlns:m="http://schemas.openxmlformats.org/officeDocument/2006/math" xmlns:a14="http://schemas.microsoft.com/office/drawing/2010/main" xmlns:ma14="http://schemas.microsoft.com/office/mac/drawingml/2011/main" val="1"/>
             </a:ext>
           </a:extLst>
         </p:spPr>
@@ -8073,7 +8073,7 @@
           </a:ln>
           <a:extLst>
             <a:ext uri="{C572A759-6A51-4108-AA02-DFA0A04FC94B}">
-              <ma14:wrappingTextBoxFlag xmlns:ma14="http://schemas.microsoft.com/office/mac/drawingml/2011/main" xmlns:a14="http://schemas.microsoft.com/office/drawing/2010/main" xmlns:m="http://schemas.openxmlformats.org/officeDocument/2006/math" xmlns="" val="1"/>
+              <ma14:wrappingTextBoxFlag xmlns="" xmlns:m="http://schemas.openxmlformats.org/officeDocument/2006/math" xmlns:a14="http://schemas.microsoft.com/office/drawing/2010/main" xmlns:ma14="http://schemas.microsoft.com/office/mac/drawingml/2011/main" val="1"/>
             </a:ext>
           </a:extLst>
         </p:spPr>
@@ -10396,7 +10396,7 @@
           </a:ln>
           <a:extLst>
             <a:ext uri="{C572A759-6A51-4108-AA02-DFA0A04FC94B}">
-              <ma14:wrappingTextBoxFlag xmlns="" xmlns:m="http://schemas.openxmlformats.org/officeDocument/2006/math" xmlns:a14="http://schemas.microsoft.com/office/drawing/2010/main" xmlns:ma14="http://schemas.microsoft.com/office/mac/drawingml/2011/main" val="1"/>
+              <ma14:wrappingTextBoxFlag xmlns:ma14="http://schemas.microsoft.com/office/mac/drawingml/2011/main" xmlns:a14="http://schemas.microsoft.com/office/drawing/2010/main" xmlns:m="http://schemas.openxmlformats.org/officeDocument/2006/math" xmlns="" val="1"/>
             </a:ext>
           </a:extLst>
         </p:spPr>
@@ -10434,7 +10434,7 @@
           </a:ln>
           <a:extLst>
             <a:ext uri="{C572A759-6A51-4108-AA02-DFA0A04FC94B}">
-              <ma14:wrappingTextBoxFlag xmlns="" xmlns:m="http://schemas.openxmlformats.org/officeDocument/2006/math" xmlns:a14="http://schemas.microsoft.com/office/drawing/2010/main" xmlns:ma14="http://schemas.microsoft.com/office/mac/drawingml/2011/main" val="1"/>
+              <ma14:wrappingTextBoxFlag xmlns:ma14="http://schemas.microsoft.com/office/mac/drawingml/2011/main" xmlns:a14="http://schemas.microsoft.com/office/drawing/2010/main" xmlns:m="http://schemas.openxmlformats.org/officeDocument/2006/math" xmlns="" val="1"/>
             </a:ext>
           </a:extLst>
         </p:spPr>
@@ -11603,7 +11603,7 @@
           </a:ln>
           <a:extLst>
             <a:ext uri="{C572A759-6A51-4108-AA02-DFA0A04FC94B}">
-              <ma14:wrappingTextBoxFlag xmlns:ma14="http://schemas.microsoft.com/office/mac/drawingml/2011/main" xmlns:a14="http://schemas.microsoft.com/office/drawing/2010/main" xmlns:m="http://schemas.openxmlformats.org/officeDocument/2006/math" xmlns="" val="1"/>
+              <ma14:wrappingTextBoxFlag xmlns="" xmlns:m="http://schemas.openxmlformats.org/officeDocument/2006/math" xmlns:a14="http://schemas.microsoft.com/office/drawing/2010/main" xmlns:ma14="http://schemas.microsoft.com/office/mac/drawingml/2011/main" val="1"/>
             </a:ext>
           </a:extLst>
         </p:spPr>
@@ -12079,7 +12079,7 @@
           </a:ln>
           <a:extLst>
             <a:ext uri="{C572A759-6A51-4108-AA02-DFA0A04FC94B}">
-              <ma14:wrappingTextBoxFlag xmlns="" xmlns:m="http://schemas.openxmlformats.org/officeDocument/2006/math" xmlns:a14="http://schemas.microsoft.com/office/drawing/2010/main" xmlns:ma14="http://schemas.microsoft.com/office/mac/drawingml/2011/main" val="1"/>
+              <ma14:wrappingTextBoxFlag xmlns:ma14="http://schemas.microsoft.com/office/mac/drawingml/2011/main" xmlns:a14="http://schemas.microsoft.com/office/drawing/2010/main" xmlns:m="http://schemas.openxmlformats.org/officeDocument/2006/math" xmlns="" val="1"/>
             </a:ext>
           </a:extLst>
         </p:spPr>
@@ -14076,7 +14076,7 @@
           </a:ln>
           <a:extLst>
             <a:ext uri="{C572A759-6A51-4108-AA02-DFA0A04FC94B}">
-              <ma14:wrappingTextBoxFlag xmlns="" xmlns:m="http://schemas.openxmlformats.org/officeDocument/2006/math" xmlns:a14="http://schemas.microsoft.com/office/drawing/2010/main" xmlns:ma14="http://schemas.microsoft.com/office/mac/drawingml/2011/main" val="1"/>
+              <ma14:wrappingTextBoxFlag xmlns:ma14="http://schemas.microsoft.com/office/mac/drawingml/2011/main" xmlns:a14="http://schemas.microsoft.com/office/drawing/2010/main" xmlns:m="http://schemas.openxmlformats.org/officeDocument/2006/math" xmlns="" val="1"/>
             </a:ext>
           </a:extLst>
         </p:spPr>
@@ -15024,7 +15024,7 @@
           </a:ln>
           <a:extLst>
             <a:ext uri="{C572A759-6A51-4108-AA02-DFA0A04FC94B}">
-              <ma14:wrappingTextBoxFlag xmlns="" xmlns:m="http://schemas.openxmlformats.org/officeDocument/2006/math" xmlns:a14="http://schemas.microsoft.com/office/drawing/2010/main" xmlns:ma14="http://schemas.microsoft.com/office/mac/drawingml/2011/main" val="1"/>
+              <ma14:wrappingTextBoxFlag xmlns:ma14="http://schemas.microsoft.com/office/mac/drawingml/2011/main" xmlns:a14="http://schemas.microsoft.com/office/drawing/2010/main" xmlns:m="http://schemas.openxmlformats.org/officeDocument/2006/math" xmlns="" val="1"/>
             </a:ext>
           </a:extLst>
         </p:spPr>
@@ -24436,7 +24436,7 @@
           </a:ln>
           <a:extLst>
             <a:ext uri="{C572A759-6A51-4108-AA02-DFA0A04FC94B}">
-              <ma14:wrappingTextBoxFlag xmlns="" xmlns:m="http://schemas.openxmlformats.org/officeDocument/2006/math" xmlns:a14="http://schemas.microsoft.com/office/drawing/2010/main" xmlns:ma14="http://schemas.microsoft.com/office/mac/drawingml/2011/main" val="1"/>
+              <ma14:wrappingTextBoxFlag xmlns:ma14="http://schemas.microsoft.com/office/mac/drawingml/2011/main" xmlns:a14="http://schemas.microsoft.com/office/drawing/2010/main" xmlns:m="http://schemas.openxmlformats.org/officeDocument/2006/math" xmlns="" val="1"/>
             </a:ext>
           </a:extLst>
         </p:spPr>
@@ -25821,7 +25821,7 @@
           </a:ln>
           <a:extLst>
             <a:ext uri="{C572A759-6A51-4108-AA02-DFA0A04FC94B}">
-              <ma14:wrappingTextBoxFlag xmlns="" xmlns:m="http://schemas.openxmlformats.org/officeDocument/2006/math" xmlns:a14="http://schemas.microsoft.com/office/drawing/2010/main" xmlns:ma14="http://schemas.microsoft.com/office/mac/drawingml/2011/main" val="1"/>
+              <ma14:wrappingTextBoxFlag xmlns:ma14="http://schemas.microsoft.com/office/mac/drawingml/2011/main" xmlns:a14="http://schemas.microsoft.com/office/drawing/2010/main" xmlns:m="http://schemas.openxmlformats.org/officeDocument/2006/math" xmlns="" val="1"/>
             </a:ext>
           </a:extLst>
         </p:spPr>
@@ -29483,7 +29483,7 @@
           </a:ln>
           <a:extLst>
             <a:ext uri="{C572A759-6A51-4108-AA02-DFA0A04FC94B}">
-              <ma14:wrappingTextBoxFlag xmlns="" xmlns:m="http://schemas.openxmlformats.org/officeDocument/2006/math" xmlns:a14="http://schemas.microsoft.com/office/drawing/2010/main" xmlns:ma14="http://schemas.microsoft.com/office/mac/drawingml/2011/main" val="1"/>
+              <ma14:wrappingTextBoxFlag xmlns:ma14="http://schemas.microsoft.com/office/mac/drawingml/2011/main" xmlns:a14="http://schemas.microsoft.com/office/drawing/2010/main" xmlns:m="http://schemas.openxmlformats.org/officeDocument/2006/math" xmlns="" val="1"/>
             </a:ext>
           </a:extLst>
         </p:spPr>
@@ -29809,6 +29809,24 @@
               <a:t>decoding</a:t>
             </a:r>
             <a:endParaRPr lang="en-US" dirty="0"/>
+          </a:p>
+          <a:p>
+            <a:pPr marL="285750" lvl="0" indent="-285750">
+              <a:buFont typeface="Wingdings" panose="05000000000000000000" pitchFamily="2" charset="2"/>
+              <a:buChar char="§"/>
+            </a:pPr>
+            <a:r>
+              <a:rPr lang="en-US" dirty="0"/>
+              <a:t>Data </a:t>
+            </a:r>
+            <a:r>
+              <a:rPr lang="en-US" b="1" dirty="0"/>
+              <a:t>compression</a:t>
+            </a:r>
+            <a:r>
+              <a:rPr lang="en-US" dirty="0"/>
+              <a:t> / decompression </a:t>
+            </a:r>
           </a:p>
           <a:p>
             <a:pPr marL="285750" lvl="0" indent="-285750">
@@ -31237,7 +31255,7 @@
           </a:ln>
           <a:extLst>
             <a:ext uri="{C572A759-6A51-4108-AA02-DFA0A04FC94B}">
-              <ma14:wrappingTextBoxFlag xmlns="" xmlns:m="http://schemas.openxmlformats.org/officeDocument/2006/math" xmlns:a14="http://schemas.microsoft.com/office/drawing/2010/main" xmlns:ma14="http://schemas.microsoft.com/office/mac/drawingml/2011/main" val="1"/>
+              <ma14:wrappingTextBoxFlag xmlns:ma14="http://schemas.microsoft.com/office/mac/drawingml/2011/main" xmlns:a14="http://schemas.microsoft.com/office/drawing/2010/main" xmlns:m="http://schemas.openxmlformats.org/officeDocument/2006/math" xmlns="" val="1"/>
             </a:ext>
           </a:extLst>
         </p:spPr>
@@ -32492,7 +32510,7 @@
         </a:ln>
         <a:extLst>
           <a:ext uri="{C572A759-6A51-4108-AA02-DFA0A04FC94B}">
-            <ma14:wrappingTextBoxFlag xmlns:ma14="http://schemas.microsoft.com/office/mac/drawingml/2011/main" xmlns:a14="http://schemas.microsoft.com/office/drawing/2010/main" xmlns:m="http://schemas.openxmlformats.org/officeDocument/2006/math" xmlns="" xmlns:p="http://schemas.openxmlformats.org/presentationml/2006/main" xmlns:r="http://schemas.openxmlformats.org/officeDocument/2006/relationships" val="1"/>
+            <ma14:wrappingTextBoxFlag xmlns:r="http://schemas.openxmlformats.org/officeDocument/2006/relationships" xmlns:p="http://schemas.openxmlformats.org/presentationml/2006/main" xmlns="" xmlns:m="http://schemas.openxmlformats.org/officeDocument/2006/math" xmlns:a14="http://schemas.microsoft.com/office/drawing/2010/main" xmlns:ma14="http://schemas.microsoft.com/office/mac/drawingml/2011/main" val="1"/>
           </a:ext>
         </a:extLst>
       </a:spPr>

</xml_diff>

<commit_message>
docs: refactor GZIP/GUNZIP from stored procedures to scalar functions
</commit_message>
<xml_diff>
--- a/Db2 Routines Presentation.pptx
+++ b/Db2 Routines Presentation.pptx
@@ -25940,14 +25940,14 @@
           <p:nvPr>
             <p:extLst>
               <p:ext uri="{D42A27DB-BD31-4B8C-83A1-F6EECF244321}">
-                <p14:modId xmlns:p14="http://schemas.microsoft.com/office/powerpoint/2010/main" val="2547139741"/>
+                <p14:modId xmlns:p14="http://schemas.microsoft.com/office/powerpoint/2010/main" val="3840208222"/>
               </p:ext>
             </p:extLst>
           </p:nvPr>
         </p:nvGraphicFramePr>
         <p:xfrm>
           <a:off x="215999" y="660816"/>
-          <a:ext cx="8583798" cy="4022103"/>
+          <a:ext cx="8583798" cy="3916020"/>
         </p:xfrm>
         <a:graphic>
           <a:graphicData uri="http://schemas.openxmlformats.org/drawingml/2006/table">
@@ -26154,7 +26154,7 @@
                   </a:ext>
                 </a:extLst>
               </a:tr>
-              <a:tr h="152236">
+              <a:tr h="0">
                 <a:tc>
                   <a:txBody>
                     <a:bodyPr/>
@@ -26164,7 +26164,7 @@
                         <a:buNone/>
                       </a:pPr>
                       <a:r>
-                        <a:rPr lang="en-US" sz="800" b="0" u="none" dirty="0">
+                        <a:rPr lang="en-US" sz="850" b="0" u="none" dirty="0">
                           <a:effectLst/>
                           <a:latin typeface="IBM Plex Mono Text" panose="020B0509050203000203" pitchFamily="49" charset="0"/>
                           <a:hlinkClick r:id="rId2" tooltip="#_apflist">
@@ -26177,7 +26177,7 @@
                         </a:rPr>
                         <a:t>APFLIST</a:t>
                       </a:r>
-                      <a:endParaRPr lang="en-US" sz="800" b="0" u="none" dirty="0">
+                      <a:endParaRPr lang="en-US" sz="850" b="0" u="none" dirty="0">
                         <a:solidFill>
                           <a:schemeClr val="tx1"/>
                         </a:solidFill>
@@ -26197,13 +26197,13 @@
                         <a:buNone/>
                       </a:pPr>
                       <a:r>
-                        <a:rPr lang="en-US" sz="800" dirty="0">
+                        <a:rPr lang="en-US" sz="850" dirty="0">
                           <a:effectLst/>
                           <a:latin typeface="IBM Plex Sans Text" panose="020B0503050203000203" pitchFamily="34" charset="0"/>
                         </a:rPr>
                         <a:t>T</a:t>
                       </a:r>
-                      <a:endParaRPr lang="en-US" sz="800" b="0" dirty="0">
+                      <a:endParaRPr lang="en-US" sz="850" b="0" dirty="0">
                         <a:solidFill>
                           <a:schemeClr val="tx1"/>
                         </a:solidFill>
@@ -26223,13 +26223,13 @@
                         <a:buNone/>
                       </a:pPr>
                       <a:r>
-                        <a:rPr lang="en-US" sz="800">
+                        <a:rPr lang="en-US" sz="850">
                           <a:effectLst/>
                           <a:latin typeface="IBM Plex Sans Text" panose="020B0503050203000203" pitchFamily="34" charset="0"/>
                         </a:rPr>
                         <a:t>System</a:t>
                       </a:r>
-                      <a:endParaRPr lang="en-US" sz="800" b="0">
+                      <a:endParaRPr lang="en-US" sz="850" b="0">
                         <a:solidFill>
                           <a:schemeClr val="tx1"/>
                         </a:solidFill>
@@ -26249,13 +26249,13 @@
                         <a:buNone/>
                       </a:pPr>
                       <a:r>
-                        <a:rPr lang="en-US" sz="800" dirty="0">
+                        <a:rPr lang="en-US" sz="850" dirty="0">
                           <a:effectLst/>
                           <a:latin typeface="IBM Plex Sans Text" panose="020B0503050203000203" pitchFamily="34" charset="0"/>
                         </a:rPr>
                         <a:t>Returns a table with all APF authorized data sets on the system.</a:t>
                       </a:r>
-                      <a:endParaRPr lang="en-US" sz="800" b="0" dirty="0">
+                      <a:endParaRPr lang="en-US" sz="850" b="0" dirty="0">
                         <a:solidFill>
                           <a:schemeClr val="tx1"/>
                         </a:solidFill>
@@ -26275,13 +26275,13 @@
                         <a:buNone/>
                       </a:pPr>
                       <a:r>
-                        <a:rPr lang="en-US" sz="800" dirty="0">
+                        <a:rPr lang="en-US" sz="850" dirty="0">
                           <a:effectLst/>
                           <a:latin typeface="IBM Plex Sans Text" panose="020B0503050203000203" pitchFamily="34" charset="0"/>
                         </a:rPr>
                         <a:t>COBOL</a:t>
                       </a:r>
-                      <a:endParaRPr lang="en-US" sz="800" b="0" dirty="0">
+                      <a:endParaRPr lang="en-US" sz="850" b="0" dirty="0">
                         <a:solidFill>
                           <a:schemeClr val="tx1"/>
                         </a:solidFill>
@@ -26298,7 +26298,7 @@
                   </a:ext>
                 </a:extLst>
               </a:tr>
-              <a:tr h="152236">
+              <a:tr h="0">
                 <a:tc>
                   <a:txBody>
                     <a:bodyPr/>
@@ -26321,7 +26321,7 @@
                         <a:tabLst/>
                       </a:pPr>
                       <a:r>
-                        <a:rPr lang="en-US" sz="800" b="0" i="0" u="none" strike="noStrike" cap="none" spc="0" baseline="0" dirty="0">
+                        <a:rPr lang="en-US" sz="850" b="0" i="0" u="none" strike="noStrike" cap="none" spc="0" baseline="0" dirty="0">
                           <a:solidFill>
                             <a:schemeClr val="tx1"/>
                           </a:solidFill>
@@ -26341,7 +26341,7 @@
                         </a:rPr>
                         <a:t>BASE64DECODE</a:t>
                       </a:r>
-                      <a:endParaRPr lang="en-US" sz="800" b="0" i="0" u="none" strike="noStrike" cap="none" spc="0" baseline="0" dirty="0">
+                      <a:endParaRPr lang="en-US" sz="850" b="0" i="0" u="none" strike="noStrike" cap="none" spc="0" baseline="0" dirty="0">
                         <a:solidFill>
                           <a:schemeClr val="tx1"/>
                         </a:solidFill>
@@ -26365,13 +26365,13 @@
                         <a:buNone/>
                       </a:pPr>
                       <a:r>
-                        <a:rPr lang="en-US" sz="800" dirty="0">
+                        <a:rPr lang="en-US" sz="850" dirty="0">
                           <a:effectLst/>
                           <a:latin typeface="IBM Plex Sans Text" panose="020B0503050203000203" pitchFamily="34" charset="0"/>
                         </a:rPr>
                         <a:t>S</a:t>
                       </a:r>
-                      <a:endParaRPr lang="en-US" sz="800" b="0" dirty="0">
+                      <a:endParaRPr lang="en-US" sz="850" b="0" dirty="0">
                         <a:solidFill>
                           <a:schemeClr val="tx1"/>
                         </a:solidFill>
@@ -26391,13 +26391,13 @@
                         <a:buNone/>
                       </a:pPr>
                       <a:r>
-                        <a:rPr lang="en-US" sz="800" dirty="0">
+                        <a:rPr lang="en-US" sz="850" dirty="0">
                           <a:effectLst/>
                           <a:latin typeface="IBM Plex Sans Text" panose="020B0503050203000203" pitchFamily="34" charset="0"/>
                         </a:rPr>
                         <a:t>Data types</a:t>
                       </a:r>
-                      <a:endParaRPr lang="en-US" sz="800" b="0" dirty="0">
+                      <a:endParaRPr lang="en-US" sz="850" b="0" dirty="0">
                         <a:solidFill>
                           <a:schemeClr val="tx1"/>
                         </a:solidFill>
@@ -26417,13 +26417,13 @@
                         <a:buNone/>
                       </a:pPr>
                       <a:r>
-                        <a:rPr lang="en-US" sz="800" dirty="0">
+                        <a:rPr lang="en-US" sz="850" dirty="0">
                           <a:effectLst/>
                           <a:latin typeface="IBM Plex Sans Text" panose="020B0503050203000203" pitchFamily="34" charset="0"/>
                         </a:rPr>
                         <a:t>Decodes BASE64 format to binary data.</a:t>
                       </a:r>
-                      <a:endParaRPr lang="en-US" sz="800" b="0" dirty="0">
+                      <a:endParaRPr lang="en-US" sz="850" b="0" dirty="0">
                         <a:solidFill>
                           <a:schemeClr val="tx1"/>
                         </a:solidFill>
@@ -26443,13 +26443,13 @@
                         <a:buNone/>
                       </a:pPr>
                       <a:r>
-                        <a:rPr lang="en-US" sz="800">
+                        <a:rPr lang="en-US" sz="850">
                           <a:effectLst/>
                           <a:latin typeface="IBM Plex Sans Text" panose="020B0503050203000203" pitchFamily="34" charset="0"/>
                         </a:rPr>
                         <a:t>Java</a:t>
                       </a:r>
-                      <a:endParaRPr lang="en-US" sz="800" b="0">
+                      <a:endParaRPr lang="en-US" sz="850" b="0">
                         <a:solidFill>
                           <a:schemeClr val="tx1"/>
                         </a:solidFill>
@@ -26466,7 +26466,7 @@
                   </a:ext>
                 </a:extLst>
               </a:tr>
-              <a:tr h="152236">
+              <a:tr h="0">
                 <a:tc>
                   <a:txBody>
                     <a:bodyPr/>
@@ -26476,7 +26476,7 @@
                         <a:buNone/>
                       </a:pPr>
                       <a:r>
-                        <a:rPr lang="en-US" sz="800" b="0" u="none" dirty="0">
+                        <a:rPr lang="en-US" sz="850" b="0" u="none" dirty="0">
                           <a:effectLst/>
                           <a:latin typeface="IBM Plex Mono Text" panose="020B0509050203000203" pitchFamily="49" charset="0"/>
                           <a:hlinkClick r:id="rId4" tooltip="#_base64encode">
@@ -26489,7 +26489,7 @@
                         </a:rPr>
                         <a:t>BASE64ENCODE</a:t>
                       </a:r>
-                      <a:endParaRPr lang="en-US" sz="800" b="0" u="none" dirty="0">
+                      <a:endParaRPr lang="en-US" sz="850" b="0" u="none" dirty="0">
                         <a:solidFill>
                           <a:schemeClr val="tx1"/>
                         </a:solidFill>
@@ -26509,13 +26509,13 @@
                         <a:buNone/>
                       </a:pPr>
                       <a:r>
-                        <a:rPr lang="en-US" sz="800" dirty="0">
+                        <a:rPr lang="en-US" sz="850" dirty="0">
                           <a:effectLst/>
                           <a:latin typeface="IBM Plex Sans Text" panose="020B0503050203000203" pitchFamily="34" charset="0"/>
                         </a:rPr>
                         <a:t>S</a:t>
                       </a:r>
-                      <a:endParaRPr lang="en-US" sz="800" b="0" dirty="0">
+                      <a:endParaRPr lang="en-US" sz="850" b="0" dirty="0">
                         <a:solidFill>
                           <a:schemeClr val="tx1"/>
                         </a:solidFill>
@@ -26535,13 +26535,13 @@
                         <a:buNone/>
                       </a:pPr>
                       <a:r>
-                        <a:rPr lang="en-US" sz="800" dirty="0">
+                        <a:rPr lang="en-US" sz="850" dirty="0">
                           <a:effectLst/>
                           <a:latin typeface="IBM Plex Sans Text" panose="020B0503050203000203" pitchFamily="34" charset="0"/>
                         </a:rPr>
                         <a:t>Data types</a:t>
                       </a:r>
-                      <a:endParaRPr lang="en-US" sz="800" b="0" dirty="0">
+                      <a:endParaRPr lang="en-US" sz="850" b="0" dirty="0">
                         <a:solidFill>
                           <a:schemeClr val="tx1"/>
                         </a:solidFill>
@@ -26561,13 +26561,13 @@
                         <a:buNone/>
                       </a:pPr>
                       <a:r>
-                        <a:rPr lang="en-US" sz="800" dirty="0">
+                        <a:rPr lang="en-US" sz="850" dirty="0">
                           <a:effectLst/>
                           <a:latin typeface="IBM Plex Sans Text" panose="020B0503050203000203" pitchFamily="34" charset="0"/>
                         </a:rPr>
                         <a:t>Encodes binary data to BASE64 format.</a:t>
                       </a:r>
-                      <a:endParaRPr lang="en-US" sz="800" b="0" dirty="0">
+                      <a:endParaRPr lang="en-US" sz="850" b="0" dirty="0">
                         <a:solidFill>
                           <a:schemeClr val="tx1"/>
                         </a:solidFill>
@@ -26587,13 +26587,13 @@
                         <a:buNone/>
                       </a:pPr>
                       <a:r>
-                        <a:rPr lang="en-US" sz="800">
+                        <a:rPr lang="en-US" sz="850">
                           <a:effectLst/>
                           <a:latin typeface="IBM Plex Sans Text" panose="020B0503050203000203" pitchFamily="34" charset="0"/>
                         </a:rPr>
                         <a:t>Java</a:t>
                       </a:r>
-                      <a:endParaRPr lang="en-US" sz="800" b="0">
+                      <a:endParaRPr lang="en-US" sz="850" b="0">
                         <a:solidFill>
                           <a:schemeClr val="tx1"/>
                         </a:solidFill>
@@ -26610,7 +26610,7 @@
                   </a:ext>
                 </a:extLst>
               </a:tr>
-              <a:tr h="152236">
+              <a:tr h="0">
                 <a:tc>
                   <a:txBody>
                     <a:bodyPr/>
@@ -26620,7 +26620,7 @@
                         <a:buNone/>
                       </a:pPr>
                       <a:r>
-                        <a:rPr lang="en-US" sz="800" b="0" u="none" dirty="0">
+                        <a:rPr lang="en-US" sz="850" b="0" u="none" dirty="0">
                           <a:effectLst/>
                           <a:latin typeface="IBM Plex Mono Text" panose="020B0509050203000203" pitchFamily="49" charset="0"/>
                           <a:hlinkClick r:id="rId5" tooltip="#_crossload">
@@ -26633,7 +26633,7 @@
                         </a:rPr>
                         <a:t>CROSSLOAD</a:t>
                       </a:r>
-                      <a:endParaRPr lang="en-US" sz="800" b="0" u="none" dirty="0">
+                      <a:endParaRPr lang="en-US" sz="850" b="0" u="none" dirty="0">
                         <a:solidFill>
                           <a:schemeClr val="tx1"/>
                         </a:solidFill>
@@ -26653,13 +26653,13 @@
                         <a:buNone/>
                       </a:pPr>
                       <a:r>
-                        <a:rPr lang="en-US" sz="800">
+                        <a:rPr lang="en-US" sz="850">
                           <a:effectLst/>
                           <a:latin typeface="IBM Plex Sans Text" panose="020B0503050203000203" pitchFamily="34" charset="0"/>
                         </a:rPr>
                         <a:t>S</a:t>
                       </a:r>
-                      <a:endParaRPr lang="en-US" sz="800" b="0">
+                      <a:endParaRPr lang="en-US" sz="850" b="0">
                         <a:solidFill>
                           <a:schemeClr val="tx1"/>
                         </a:solidFill>
@@ -26679,13 +26679,13 @@
                         <a:buNone/>
                       </a:pPr>
                       <a:r>
-                        <a:rPr lang="en-US" sz="800" dirty="0">
+                        <a:rPr lang="en-US" sz="850" dirty="0">
                           <a:effectLst/>
                           <a:latin typeface="IBM Plex Sans Text" panose="020B0503050203000203" pitchFamily="34" charset="0"/>
                         </a:rPr>
                         <a:t>Utilities</a:t>
                       </a:r>
-                      <a:endParaRPr lang="en-US" sz="800" b="0" dirty="0">
+                      <a:endParaRPr lang="en-US" sz="850" b="0" dirty="0">
                         <a:solidFill>
                           <a:schemeClr val="tx1"/>
                         </a:solidFill>
@@ -26705,13 +26705,13 @@
                         <a:buNone/>
                       </a:pPr>
                       <a:r>
-                        <a:rPr lang="en-US" sz="800" dirty="0">
+                        <a:rPr lang="en-US" sz="850" dirty="0">
                           <a:effectLst/>
                           <a:latin typeface="IBM Plex Sans Text" panose="020B0503050203000203" pitchFamily="34" charset="0"/>
                         </a:rPr>
                         <a:t>Copies data from one table to another.</a:t>
                       </a:r>
-                      <a:endParaRPr lang="en-US" sz="800" b="0" dirty="0">
+                      <a:endParaRPr lang="en-US" sz="850" b="0" dirty="0">
                         <a:solidFill>
                           <a:schemeClr val="tx1"/>
                         </a:solidFill>
@@ -26731,13 +26731,13 @@
                         <a:buNone/>
                       </a:pPr>
                       <a:r>
-                        <a:rPr lang="en-US" sz="800">
+                        <a:rPr lang="en-US" sz="850">
                           <a:effectLst/>
                           <a:latin typeface="IBM Plex Sans Text" panose="020B0503050203000203" pitchFamily="34" charset="0"/>
                         </a:rPr>
                         <a:t>SQL</a:t>
                       </a:r>
-                      <a:endParaRPr lang="en-US" sz="800" b="0">
+                      <a:endParaRPr lang="en-US" sz="850" b="0">
                         <a:solidFill>
                           <a:schemeClr val="tx1"/>
                         </a:solidFill>
@@ -26754,7 +26754,7 @@
                   </a:ext>
                 </a:extLst>
               </a:tr>
-              <a:tr h="152236">
+              <a:tr h="0">
                 <a:tc>
                   <a:txBody>
                     <a:bodyPr/>
@@ -26764,7 +26764,7 @@
                         <a:buNone/>
                       </a:pPr>
                       <a:r>
-                        <a:rPr lang="en-US" sz="800" b="0" u="none" dirty="0">
+                        <a:rPr lang="en-US" sz="850" b="0" u="none" dirty="0">
                           <a:effectLst/>
                           <a:latin typeface="IBM Plex Mono Text" panose="020B0509050203000203" pitchFamily="49" charset="0"/>
                           <a:hlinkClick r:id="rId6" tooltip="#_db2utility">
@@ -26777,7 +26777,7 @@
                         </a:rPr>
                         <a:t>DB2UTILITY</a:t>
                       </a:r>
-                      <a:endParaRPr lang="en-US" sz="800" b="0" u="none" dirty="0">
+                      <a:endParaRPr lang="en-US" sz="850" b="0" u="none" dirty="0">
                         <a:solidFill>
                           <a:schemeClr val="tx1"/>
                         </a:solidFill>
@@ -26797,13 +26797,13 @@
                         <a:buNone/>
                       </a:pPr>
                       <a:r>
-                        <a:rPr lang="en-US" sz="800">
+                        <a:rPr lang="en-US" sz="850">
                           <a:effectLst/>
                           <a:latin typeface="IBM Plex Sans Text" panose="020B0503050203000203" pitchFamily="34" charset="0"/>
                         </a:rPr>
                         <a:t>S</a:t>
                       </a:r>
-                      <a:endParaRPr lang="en-US" sz="800" b="0">
+                      <a:endParaRPr lang="en-US" sz="850" b="0">
                         <a:solidFill>
                           <a:schemeClr val="tx1"/>
                         </a:solidFill>
@@ -26823,13 +26823,13 @@
                         <a:buNone/>
                       </a:pPr>
                       <a:r>
-                        <a:rPr lang="en-US" sz="800" dirty="0">
+                        <a:rPr lang="en-US" sz="850" dirty="0">
                           <a:effectLst/>
                           <a:latin typeface="IBM Plex Sans Text" panose="020B0503050203000203" pitchFamily="34" charset="0"/>
                         </a:rPr>
                         <a:t>Utilities</a:t>
                       </a:r>
-                      <a:endParaRPr lang="en-US" sz="800" b="0" dirty="0">
+                      <a:endParaRPr lang="en-US" sz="850" b="0" dirty="0">
                         <a:solidFill>
                           <a:schemeClr val="tx1"/>
                         </a:solidFill>
@@ -26849,13 +26849,13 @@
                         <a:buNone/>
                       </a:pPr>
                       <a:r>
-                        <a:rPr lang="en-US" sz="800" dirty="0">
+                        <a:rPr lang="en-US" sz="850" dirty="0">
                           <a:effectLst/>
                           <a:latin typeface="IBM Plex Sans Text" panose="020B0503050203000203" pitchFamily="34" charset="0"/>
                         </a:rPr>
                         <a:t>Runs one or more Db2 utility statements.</a:t>
                       </a:r>
-                      <a:endParaRPr lang="en-US" sz="800" b="0" dirty="0">
+                      <a:endParaRPr lang="en-US" sz="850" b="0" dirty="0">
                         <a:solidFill>
                           <a:schemeClr val="tx1"/>
                         </a:solidFill>
@@ -26875,13 +26875,13 @@
                         <a:buNone/>
                       </a:pPr>
                       <a:r>
-                        <a:rPr lang="en-US" sz="800">
+                        <a:rPr lang="en-US" sz="850">
                           <a:effectLst/>
                           <a:latin typeface="IBM Plex Sans Text" panose="020B0503050203000203" pitchFamily="34" charset="0"/>
                         </a:rPr>
                         <a:t>SQL</a:t>
                       </a:r>
-                      <a:endParaRPr lang="en-US" sz="800" b="0">
+                      <a:endParaRPr lang="en-US" sz="850" b="0">
                         <a:solidFill>
                           <a:schemeClr val="tx1"/>
                         </a:solidFill>
@@ -26898,7 +26898,7 @@
                   </a:ext>
                 </a:extLst>
               </a:tr>
-              <a:tr h="152236">
+              <a:tr h="0">
                 <a:tc>
                   <a:txBody>
                     <a:bodyPr/>
@@ -26908,7 +26908,7 @@
                         <a:buNone/>
                       </a:pPr>
                       <a:r>
-                        <a:rPr lang="en-US" sz="800" b="0" u="none">
+                        <a:rPr lang="en-US" sz="850" b="0" u="none">
                           <a:effectLst/>
                           <a:latin typeface="IBM Plex Mono Text" panose="020B0509050203000203" pitchFamily="49" charset="0"/>
                           <a:hlinkClick r:id="rId7" tooltip="#_easter">
@@ -26921,7 +26921,7 @@
                         </a:rPr>
                         <a:t>EASTER</a:t>
                       </a:r>
-                      <a:endParaRPr lang="en-US" sz="800" b="0" u="none">
+                      <a:endParaRPr lang="en-US" sz="850" b="0" u="none">
                         <a:solidFill>
                           <a:schemeClr val="tx1"/>
                         </a:solidFill>
@@ -26941,13 +26941,13 @@
                         <a:buNone/>
                       </a:pPr>
                       <a:r>
-                        <a:rPr lang="en-US" sz="800">
+                        <a:rPr lang="en-US" sz="850" dirty="0">
                           <a:effectLst/>
                           <a:latin typeface="IBM Plex Sans Text" panose="020B0503050203000203" pitchFamily="34" charset="0"/>
                         </a:rPr>
                         <a:t>S</a:t>
                       </a:r>
-                      <a:endParaRPr lang="en-US" sz="800" b="0">
+                      <a:endParaRPr lang="en-US" sz="850" b="0" dirty="0">
                         <a:solidFill>
                           <a:schemeClr val="tx1"/>
                         </a:solidFill>
@@ -26967,13 +26967,13 @@
                         <a:buNone/>
                       </a:pPr>
                       <a:r>
-                        <a:rPr lang="en-US" sz="800" dirty="0">
+                        <a:rPr lang="en-US" sz="850" dirty="0">
                           <a:effectLst/>
                           <a:latin typeface="IBM Plex Sans Text" panose="020B0503050203000203" pitchFamily="34" charset="0"/>
                         </a:rPr>
                         <a:t>Date and time</a:t>
                       </a:r>
-                      <a:endParaRPr lang="en-US" sz="800" b="0" dirty="0">
+                      <a:endParaRPr lang="en-US" sz="850" b="0" dirty="0">
                         <a:solidFill>
                           <a:schemeClr val="tx1"/>
                         </a:solidFill>
@@ -26993,13 +26993,13 @@
                         <a:buNone/>
                       </a:pPr>
                       <a:r>
-                        <a:rPr lang="en-US" sz="800" dirty="0">
+                        <a:rPr lang="en-US" sz="850" dirty="0">
                           <a:effectLst/>
                           <a:latin typeface="IBM Plex Sans Text" panose="020B0503050203000203" pitchFamily="34" charset="0"/>
                         </a:rPr>
                         <a:t>Calculates the date of Easter for a given year.</a:t>
                       </a:r>
-                      <a:endParaRPr lang="en-US" sz="800" b="0" dirty="0">
+                      <a:endParaRPr lang="en-US" sz="850" b="0" dirty="0">
                         <a:solidFill>
                           <a:schemeClr val="tx1"/>
                         </a:solidFill>
@@ -27019,13 +27019,13 @@
                         <a:buNone/>
                       </a:pPr>
                       <a:r>
-                        <a:rPr lang="en-US" sz="800">
+                        <a:rPr lang="en-US" sz="850">
                           <a:effectLst/>
                           <a:latin typeface="IBM Plex Sans Text" panose="020B0503050203000203" pitchFamily="34" charset="0"/>
                         </a:rPr>
                         <a:t>SQL</a:t>
                       </a:r>
-                      <a:endParaRPr lang="en-US" sz="800" b="0">
+                      <a:endParaRPr lang="en-US" sz="850" b="0">
                         <a:solidFill>
                           <a:schemeClr val="tx1"/>
                         </a:solidFill>
@@ -27042,7 +27042,7 @@
                   </a:ext>
                 </a:extLst>
               </a:tr>
-              <a:tr h="152236">
+              <a:tr h="0">
                 <a:tc>
                   <a:txBody>
                     <a:bodyPr/>
@@ -27052,7 +27052,7 @@
                         <a:buNone/>
                       </a:pPr>
                       <a:r>
-                        <a:rPr lang="en-US" sz="800" b="0" u="none" dirty="0">
+                        <a:rPr lang="en-US" sz="850" b="0" u="none" dirty="0">
                           <a:effectLst/>
                           <a:latin typeface="IBM Plex Mono Text" panose="020B0509050203000203" pitchFamily="49" charset="0"/>
                           <a:hlinkClick r:id="rId8" tooltip="#_formattimestamp">
@@ -27065,7 +27065,7 @@
                         </a:rPr>
                         <a:t>FORMATTIMESTAMP</a:t>
                       </a:r>
-                      <a:endParaRPr lang="en-US" sz="800" b="0" u="none" dirty="0">
+                      <a:endParaRPr lang="en-US" sz="850" b="0" u="none" dirty="0">
                         <a:solidFill>
                           <a:schemeClr val="tx1"/>
                         </a:solidFill>
@@ -27085,13 +27085,13 @@
                         <a:buNone/>
                       </a:pPr>
                       <a:r>
-                        <a:rPr lang="en-US" sz="800">
+                        <a:rPr lang="en-US" sz="850">
                           <a:effectLst/>
                           <a:latin typeface="IBM Plex Sans Text" panose="020B0503050203000203" pitchFamily="34" charset="0"/>
                         </a:rPr>
                         <a:t>S</a:t>
                       </a:r>
-                      <a:endParaRPr lang="en-US" sz="800" b="0">
+                      <a:endParaRPr lang="en-US" sz="850" b="0">
                         <a:solidFill>
                           <a:schemeClr val="tx1"/>
                         </a:solidFill>
@@ -27111,13 +27111,13 @@
                         <a:buNone/>
                       </a:pPr>
                       <a:r>
-                        <a:rPr lang="en-US" sz="800" dirty="0">
+                        <a:rPr lang="en-US" sz="850" dirty="0">
                           <a:effectLst/>
                           <a:latin typeface="IBM Plex Sans Text" panose="020B0503050203000203" pitchFamily="34" charset="0"/>
                         </a:rPr>
                         <a:t>Date and time</a:t>
                       </a:r>
-                      <a:endParaRPr lang="en-US" sz="800" b="0" dirty="0">
+                      <a:endParaRPr lang="en-US" sz="850" b="0" dirty="0">
                         <a:solidFill>
                           <a:schemeClr val="tx1"/>
                         </a:solidFill>
@@ -27137,13 +27137,13 @@
                         <a:buNone/>
                       </a:pPr>
                       <a:r>
-                        <a:rPr lang="en-US" sz="800" dirty="0">
+                        <a:rPr lang="en-US" sz="850" dirty="0">
                           <a:effectLst/>
                           <a:latin typeface="IBM Plex Sans Text" panose="020B0503050203000203" pitchFamily="34" charset="0"/>
                         </a:rPr>
                         <a:t>Locale-sensitive formatting of a timestamp value.</a:t>
                       </a:r>
-                      <a:endParaRPr lang="en-US" sz="800" b="0" dirty="0">
+                      <a:endParaRPr lang="en-US" sz="850" b="0" dirty="0">
                         <a:solidFill>
                           <a:schemeClr val="tx1"/>
                         </a:solidFill>
@@ -27163,13 +27163,13 @@
                         <a:buNone/>
                       </a:pPr>
                       <a:r>
-                        <a:rPr lang="en-US" sz="800">
+                        <a:rPr lang="en-US" sz="850">
                           <a:effectLst/>
                           <a:latin typeface="IBM Plex Sans Text" panose="020B0503050203000203" pitchFamily="34" charset="0"/>
                         </a:rPr>
                         <a:t>Java</a:t>
                       </a:r>
-                      <a:endParaRPr lang="en-US" sz="800" b="0">
+                      <a:endParaRPr lang="en-US" sz="850" b="0">
                         <a:solidFill>
                           <a:schemeClr val="tx1"/>
                         </a:solidFill>
@@ -27186,7 +27186,7 @@
                   </a:ext>
                 </a:extLst>
               </a:tr>
-              <a:tr h="283529">
+              <a:tr h="0">
                 <a:tc>
                   <a:txBody>
                     <a:bodyPr/>
@@ -27196,7 +27196,7 @@
                         <a:buNone/>
                       </a:pPr>
                       <a:r>
-                        <a:rPr lang="en-US" sz="800" b="0" u="none" dirty="0">
+                        <a:rPr lang="en-US" sz="850" b="0" u="none" dirty="0">
                           <a:effectLst/>
                           <a:latin typeface="IBM Plex Mono Text" panose="020B0509050203000203" pitchFamily="49" charset="0"/>
                           <a:hlinkClick r:id="rId9" tooltip="#_generate_series">
@@ -27209,7 +27209,7 @@
                         </a:rPr>
                         <a:t>GENERATE_SERIES</a:t>
                       </a:r>
-                      <a:endParaRPr lang="en-US" sz="800" b="0" u="none" dirty="0">
+                      <a:endParaRPr lang="en-US" sz="850" b="0" u="none" dirty="0">
                         <a:solidFill>
                           <a:schemeClr val="tx1"/>
                         </a:solidFill>
@@ -27229,13 +27229,13 @@
                         <a:buNone/>
                       </a:pPr>
                       <a:r>
-                        <a:rPr lang="en-US" sz="800" dirty="0">
+                        <a:rPr lang="en-US" sz="850" dirty="0">
                           <a:effectLst/>
                           <a:latin typeface="IBM Plex Sans Text" panose="020B0503050203000203" pitchFamily="34" charset="0"/>
                         </a:rPr>
                         <a:t>T</a:t>
                       </a:r>
-                      <a:endParaRPr lang="en-US" sz="800" b="0" dirty="0">
+                      <a:endParaRPr lang="en-US" sz="850" b="0" dirty="0">
                         <a:solidFill>
                           <a:schemeClr val="tx1"/>
                         </a:solidFill>
@@ -27255,13 +27255,13 @@
                         <a:buNone/>
                       </a:pPr>
                       <a:r>
-                        <a:rPr lang="en-US" sz="800" dirty="0">
+                        <a:rPr lang="en-US" sz="850" dirty="0">
                           <a:effectLst/>
                           <a:latin typeface="IBM Plex Sans Text" panose="020B0503050203000203" pitchFamily="34" charset="0"/>
                         </a:rPr>
                         <a:t>Data types</a:t>
                       </a:r>
-                      <a:endParaRPr lang="en-US" sz="800" b="0" dirty="0">
+                      <a:endParaRPr lang="en-US" sz="850" b="0" dirty="0">
                         <a:solidFill>
                           <a:schemeClr val="tx1"/>
                         </a:solidFill>
@@ -27281,13 +27281,13 @@
                         <a:buNone/>
                       </a:pPr>
                       <a:r>
-                        <a:rPr lang="en-US" sz="800" dirty="0">
+                        <a:rPr lang="en-US" sz="850" dirty="0">
                           <a:effectLst/>
                           <a:latin typeface="IBM Plex Sans Text" panose="020B0503050203000203" pitchFamily="34" charset="0"/>
                         </a:rPr>
                         <a:t>Generate a series of values between a start and an end value, with an optional step.</a:t>
                       </a:r>
-                      <a:endParaRPr lang="en-US" sz="800" b="0" dirty="0">
+                      <a:endParaRPr lang="en-US" sz="850" b="0" dirty="0">
                         <a:solidFill>
                           <a:schemeClr val="tx1"/>
                         </a:solidFill>
@@ -27307,13 +27307,13 @@
                         <a:buNone/>
                       </a:pPr>
                       <a:r>
-                        <a:rPr lang="en-US" sz="800">
+                        <a:rPr lang="en-US" sz="850">
                           <a:effectLst/>
                           <a:latin typeface="IBM Plex Sans Text" panose="020B0503050203000203" pitchFamily="34" charset="0"/>
                         </a:rPr>
                         <a:t>SQL</a:t>
                       </a:r>
-                      <a:endParaRPr lang="en-US" sz="800" b="0">
+                      <a:endParaRPr lang="en-US" sz="850" b="0">
                         <a:solidFill>
                           <a:schemeClr val="tx1"/>
                         </a:solidFill>
@@ -27330,7 +27330,7 @@
                   </a:ext>
                 </a:extLst>
               </a:tr>
-              <a:tr h="152236">
+              <a:tr h="0">
                 <a:tc>
                   <a:txBody>
                     <a:bodyPr/>
@@ -27340,7 +27340,141 @@
                         <a:buNone/>
                       </a:pPr>
                       <a:r>
-                        <a:rPr lang="en-US" sz="800" b="0" u="none">
+                        <a:rPr lang="en-US" sz="850" b="0" u="none" dirty="0">
+                          <a:solidFill>
+                            <a:schemeClr val="tx1"/>
+                          </a:solidFill>
+                          <a:effectLst/>
+                          <a:latin typeface="IBM Plex Mono Text" panose="020B0509050203000203" pitchFamily="49" charset="0"/>
+                        </a:rPr>
+                        <a:t>GZIP, GUNZIP</a:t>
+                      </a:r>
+                    </a:p>
+                  </a:txBody>
+                  <a:tcPr marL="21880" marR="21880" marT="10940" marB="10940"/>
+                </a:tc>
+                <a:tc>
+                  <a:txBody>
+                    <a:bodyPr/>
+                    <a:lstStyle/>
+                    <a:p>
+                      <a:pPr algn="l" rtl="0" fontAlgn="t">
+                        <a:buNone/>
+                      </a:pPr>
+                      <a:r>
+                        <a:rPr lang="en-US" sz="850" b="0" dirty="0">
+                          <a:solidFill>
+                            <a:schemeClr val="tx1"/>
+                          </a:solidFill>
+                          <a:effectLst/>
+                          <a:latin typeface="IBM Plex Sans Text" panose="020B0503050203000203" pitchFamily="34" charset="0"/>
+                        </a:rPr>
+                        <a:t>S</a:t>
+                      </a:r>
+                    </a:p>
+                  </a:txBody>
+                  <a:tcPr marL="21880" marR="21880" marT="10940" marB="10940"/>
+                </a:tc>
+                <a:tc>
+                  <a:txBody>
+                    <a:bodyPr/>
+                    <a:lstStyle/>
+                    <a:p>
+                      <a:pPr algn="l" rtl="0" fontAlgn="t">
+                        <a:buNone/>
+                      </a:pPr>
+                      <a:r>
+                        <a:rPr lang="en-US" sz="850" b="0" dirty="0">
+                          <a:solidFill>
+                            <a:schemeClr val="tx1"/>
+                          </a:solidFill>
+                          <a:effectLst/>
+                          <a:latin typeface="IBM Plex Sans Text" panose="020B0503050203000203" pitchFamily="34" charset="0"/>
+                        </a:rPr>
+                        <a:t>Data types</a:t>
+                      </a:r>
+                    </a:p>
+                  </a:txBody>
+                  <a:tcPr marL="21880" marR="21880" marT="10940" marB="10940"/>
+                </a:tc>
+                <a:tc>
+                  <a:txBody>
+                    <a:bodyPr/>
+                    <a:lstStyle/>
+                    <a:p>
+                      <a:pPr algn="l" rtl="0" fontAlgn="t">
+                        <a:buNone/>
+                      </a:pPr>
+                      <a:r>
+                        <a:rPr lang="en-US" sz="850" b="0" dirty="0">
+                          <a:solidFill>
+                            <a:schemeClr val="tx1"/>
+                          </a:solidFill>
+                          <a:effectLst/>
+                          <a:latin typeface="IBM Plex Sans Text" panose="020B0503050203000203" pitchFamily="34" charset="0"/>
+                        </a:rPr>
+                        <a:t>Data compression and decompression using </a:t>
+                      </a:r>
+                      <a:r>
+                        <a:rPr lang="en-US" sz="850" b="0" dirty="0" err="1">
+                          <a:solidFill>
+                            <a:schemeClr val="tx1"/>
+                          </a:solidFill>
+                          <a:effectLst/>
+                          <a:latin typeface="IBM Plex Sans Text" panose="020B0503050203000203" pitchFamily="34" charset="0"/>
+                        </a:rPr>
+                        <a:t>Gzip</a:t>
+                      </a:r>
+                      <a:endParaRPr lang="en-US" sz="850" b="0" dirty="0">
+                        <a:solidFill>
+                          <a:schemeClr val="tx1"/>
+                        </a:solidFill>
+                        <a:effectLst/>
+                        <a:latin typeface="IBM Plex Sans Text" panose="020B0503050203000203" pitchFamily="34" charset="0"/>
+                      </a:endParaRPr>
+                    </a:p>
+                  </a:txBody>
+                  <a:tcPr marL="21880" marR="21880" marT="10940" marB="10940"/>
+                </a:tc>
+                <a:tc>
+                  <a:txBody>
+                    <a:bodyPr/>
+                    <a:lstStyle/>
+                    <a:p>
+                      <a:pPr algn="l" rtl="0" fontAlgn="t">
+                        <a:buNone/>
+                      </a:pPr>
+                      <a:r>
+                        <a:rPr lang="en-US" sz="850" b="0" dirty="0">
+                          <a:solidFill>
+                            <a:schemeClr val="tx1"/>
+                          </a:solidFill>
+                          <a:effectLst/>
+                          <a:latin typeface="IBM Plex Sans Text" panose="020B0503050203000203" pitchFamily="34" charset="0"/>
+                        </a:rPr>
+                        <a:t>Java</a:t>
+                      </a:r>
+                    </a:p>
+                  </a:txBody>
+                  <a:tcPr marL="21880" marR="21880" marT="10940" marB="10940"/>
+                </a:tc>
+                <a:extLst>
+                  <a:ext uri="{0D108BD9-81ED-4DB2-BD59-A6C34878D82A}">
+                    <a16:rowId xmlns:a16="http://schemas.microsoft.com/office/drawing/2014/main" val="1597548128"/>
+                  </a:ext>
+                </a:extLst>
+              </a:tr>
+              <a:tr h="0">
+                <a:tc>
+                  <a:txBody>
+                    <a:bodyPr/>
+                    <a:lstStyle/>
+                    <a:p>
+                      <a:pPr algn="l" rtl="0" fontAlgn="t">
+                        <a:buNone/>
+                      </a:pPr>
+                      <a:r>
+                        <a:rPr lang="en-US" sz="850" b="0" u="none" dirty="0">
                           <a:effectLst/>
                           <a:latin typeface="IBM Plex Mono Text" panose="020B0509050203000203" pitchFamily="49" charset="0"/>
                           <a:hlinkClick r:id="rId10" tooltip="#_hextoint">
@@ -27353,7 +27487,7 @@
                         </a:rPr>
                         <a:t>HEXTOINT</a:t>
                       </a:r>
-                      <a:endParaRPr lang="en-US" sz="800" b="0" u="none">
+                      <a:endParaRPr lang="en-US" sz="850" b="0" u="none" dirty="0">
                         <a:solidFill>
                           <a:schemeClr val="tx1"/>
                         </a:solidFill>
@@ -27373,13 +27507,13 @@
                         <a:buNone/>
                       </a:pPr>
                       <a:r>
-                        <a:rPr lang="en-US" sz="800">
+                        <a:rPr lang="en-US" sz="850">
                           <a:effectLst/>
                           <a:latin typeface="IBM Plex Sans Text" panose="020B0503050203000203" pitchFamily="34" charset="0"/>
                         </a:rPr>
                         <a:t>S</a:t>
                       </a:r>
-                      <a:endParaRPr lang="en-US" sz="800" b="0">
+                      <a:endParaRPr lang="en-US" sz="850" b="0">
                         <a:solidFill>
                           <a:schemeClr val="tx1"/>
                         </a:solidFill>
@@ -27399,13 +27533,13 @@
                         <a:buNone/>
                       </a:pPr>
                       <a:r>
-                        <a:rPr lang="en-US" sz="800" dirty="0">
+                        <a:rPr lang="en-US" sz="850" dirty="0">
                           <a:effectLst/>
                           <a:latin typeface="IBM Plex Sans Text" panose="020B0503050203000203" pitchFamily="34" charset="0"/>
                         </a:rPr>
                         <a:t>Data types</a:t>
                       </a:r>
-                      <a:endParaRPr lang="en-US" sz="800" b="0" dirty="0">
+                      <a:endParaRPr lang="en-US" sz="850" b="0" dirty="0">
                         <a:solidFill>
                           <a:schemeClr val="tx1"/>
                         </a:solidFill>
@@ -27425,13 +27559,13 @@
                         <a:buNone/>
                       </a:pPr>
                       <a:r>
-                        <a:rPr lang="en-US" sz="800" dirty="0">
+                        <a:rPr lang="en-US" sz="850" dirty="0">
                           <a:effectLst/>
                           <a:latin typeface="IBM Plex Sans Text" panose="020B0503050203000203" pitchFamily="34" charset="0"/>
                         </a:rPr>
                         <a:t>Converts a hex string to integer.</a:t>
                       </a:r>
-                      <a:endParaRPr lang="en-US" sz="800" b="0" dirty="0">
+                      <a:endParaRPr lang="en-US" sz="850" b="0" dirty="0">
                         <a:solidFill>
                           <a:schemeClr val="tx1"/>
                         </a:solidFill>
@@ -27451,13 +27585,13 @@
                         <a:buNone/>
                       </a:pPr>
                       <a:r>
-                        <a:rPr lang="en-US" sz="800">
+                        <a:rPr lang="en-US" sz="850">
                           <a:effectLst/>
                           <a:latin typeface="IBM Plex Sans Text" panose="020B0503050203000203" pitchFamily="34" charset="0"/>
                         </a:rPr>
                         <a:t>SQL</a:t>
                       </a:r>
-                      <a:endParaRPr lang="en-US" sz="800" b="0">
+                      <a:endParaRPr lang="en-US" sz="850" b="0">
                         <a:solidFill>
                           <a:schemeClr val="tx1"/>
                         </a:solidFill>
@@ -27474,7 +27608,7 @@
                   </a:ext>
                 </a:extLst>
               </a:tr>
-              <a:tr h="152236">
+              <a:tr h="0">
                 <a:tc>
                   <a:txBody>
                     <a:bodyPr/>
@@ -27484,7 +27618,7 @@
                         <a:buNone/>
                       </a:pPr>
                       <a:r>
-                        <a:rPr lang="en-US" sz="800" b="0" i="0" u="none" strike="noStrike" cap="none" spc="0" baseline="0" dirty="0">
+                        <a:rPr lang="en-US" sz="850" b="0" i="0" u="none" strike="noStrike" cap="none" spc="0" baseline="0" dirty="0">
                           <a:solidFill>
                             <a:schemeClr val="tx1"/>
                           </a:solidFill>
@@ -27504,7 +27638,7 @@
                         </a:rPr>
                         <a:t>RACFPROFILE</a:t>
                       </a:r>
-                      <a:endParaRPr lang="en-US" sz="800" b="0" i="0" u="none" strike="noStrike" cap="none" spc="0" baseline="0" dirty="0">
+                      <a:endParaRPr lang="en-US" sz="850" b="0" i="0" u="none" strike="noStrike" cap="none" spc="0" baseline="0" dirty="0">
                         <a:solidFill>
                           <a:schemeClr val="tx1"/>
                         </a:solidFill>
@@ -27528,7 +27662,7 @@
                         <a:buNone/>
                       </a:pPr>
                       <a:r>
-                        <a:rPr lang="en-US" sz="800" b="0" i="0" u="none" strike="noStrike" cap="none" spc="0" baseline="0" dirty="0">
+                        <a:rPr lang="en-US" sz="850" b="0" i="0" u="none" strike="noStrike" cap="none" spc="0" baseline="0" dirty="0">
                           <a:solidFill>
                             <a:schemeClr val="tx1"/>
                           </a:solidFill>
@@ -27554,13 +27688,13 @@
                         <a:buNone/>
                       </a:pPr>
                       <a:r>
-                        <a:rPr lang="en-US" sz="800">
+                        <a:rPr lang="en-US" sz="850">
                           <a:effectLst/>
                           <a:latin typeface="IBM Plex Sans Text" panose="020B0503050203000203" pitchFamily="34" charset="0"/>
                         </a:rPr>
                         <a:t>System</a:t>
                       </a:r>
-                      <a:endParaRPr lang="en-US" sz="800" b="0">
+                      <a:endParaRPr lang="en-US" sz="850" b="0">
                         <a:solidFill>
                           <a:schemeClr val="tx1"/>
                         </a:solidFill>
@@ -27580,13 +27714,13 @@
                         <a:buNone/>
                       </a:pPr>
                       <a:r>
-                        <a:rPr lang="en-US" sz="800" dirty="0">
+                        <a:rPr lang="en-US" sz="850" dirty="0">
                           <a:effectLst/>
                           <a:latin typeface="IBM Plex Sans Text" panose="020B0503050203000203" pitchFamily="34" charset="0"/>
                         </a:rPr>
                         <a:t>Returns the RACF profile that covers the input data set name.</a:t>
                       </a:r>
-                      <a:endParaRPr lang="en-US" sz="800" b="0" dirty="0">
+                      <a:endParaRPr lang="en-US" sz="850" b="0" dirty="0">
                         <a:solidFill>
                           <a:schemeClr val="tx1"/>
                         </a:solidFill>
@@ -27606,13 +27740,13 @@
                         <a:buNone/>
                       </a:pPr>
                       <a:r>
-                        <a:rPr lang="en-US" sz="800">
+                        <a:rPr lang="en-US" sz="850">
                           <a:effectLst/>
                           <a:latin typeface="IBM Plex Sans Text" panose="020B0503050203000203" pitchFamily="34" charset="0"/>
                         </a:rPr>
                         <a:t>COBOL</a:t>
                       </a:r>
-                      <a:endParaRPr lang="en-US" sz="800" b="0">
+                      <a:endParaRPr lang="en-US" sz="850" b="0">
                         <a:solidFill>
                           <a:schemeClr val="tx1"/>
                         </a:solidFill>
@@ -27629,7 +27763,7 @@
                   </a:ext>
                 </a:extLst>
               </a:tr>
-              <a:tr h="152236">
+              <a:tr h="0">
                 <a:tc>
                   <a:txBody>
                     <a:bodyPr/>
@@ -27639,7 +27773,7 @@
                         <a:buNone/>
                       </a:pPr>
                       <a:r>
-                        <a:rPr lang="en-US" sz="800" b="0" u="none">
+                        <a:rPr lang="en-US" sz="850" b="0" u="none">
                           <a:effectLst/>
                           <a:latin typeface="IBM Plex Mono Text" panose="020B0509050203000203" pitchFamily="49" charset="0"/>
                           <a:hlinkClick r:id="rId12" tooltip="#_read_generic_file">
@@ -27652,7 +27786,7 @@
                         </a:rPr>
                         <a:t>READ_GENERIC_FILE</a:t>
                       </a:r>
-                      <a:endParaRPr lang="en-US" sz="800" b="0" u="none">
+                      <a:endParaRPr lang="en-US" sz="850" b="0" u="none">
                         <a:solidFill>
                           <a:schemeClr val="tx1"/>
                         </a:solidFill>
@@ -27672,7 +27806,7 @@
                         <a:buNone/>
                       </a:pPr>
                       <a:r>
-                        <a:rPr lang="en-US" sz="800" b="0" i="0" u="none" strike="noStrike" cap="none" spc="0" baseline="0" dirty="0">
+                        <a:rPr lang="en-US" sz="850" b="0" i="0" u="none" strike="noStrike" cap="none" spc="0" baseline="0" dirty="0">
                           <a:solidFill>
                             <a:schemeClr val="tx1"/>
                           </a:solidFill>
@@ -27698,13 +27832,13 @@
                         <a:buNone/>
                       </a:pPr>
                       <a:r>
-                        <a:rPr lang="en-US" sz="800">
+                        <a:rPr lang="en-US" sz="850">
                           <a:effectLst/>
                           <a:latin typeface="IBM Plex Sans Text" panose="020B0503050203000203" pitchFamily="34" charset="0"/>
                         </a:rPr>
                         <a:t>System</a:t>
                       </a:r>
-                      <a:endParaRPr lang="en-US" sz="800" b="0">
+                      <a:endParaRPr lang="en-US" sz="850" b="0">
                         <a:solidFill>
                           <a:schemeClr val="tx1"/>
                         </a:solidFill>
@@ -27724,13 +27858,13 @@
                         <a:buNone/>
                       </a:pPr>
                       <a:r>
-                        <a:rPr lang="en-US" sz="800" dirty="0">
+                        <a:rPr lang="en-US" sz="850" dirty="0">
                           <a:effectLst/>
                           <a:latin typeface="IBM Plex Sans Text" panose="020B0503050203000203" pitchFamily="34" charset="0"/>
                         </a:rPr>
                         <a:t>Reads records from a flat file and returns them as a table.</a:t>
                       </a:r>
-                      <a:endParaRPr lang="en-US" sz="800" b="0" dirty="0">
+                      <a:endParaRPr lang="en-US" sz="850" b="0" dirty="0">
                         <a:solidFill>
                           <a:schemeClr val="tx1"/>
                         </a:solidFill>
@@ -27750,13 +27884,13 @@
                         <a:buNone/>
                       </a:pPr>
                       <a:r>
-                        <a:rPr lang="en-US" sz="800">
+                        <a:rPr lang="en-US" sz="850">
                           <a:effectLst/>
                           <a:latin typeface="IBM Plex Sans Text" panose="020B0503050203000203" pitchFamily="34" charset="0"/>
                         </a:rPr>
                         <a:t>C</a:t>
                       </a:r>
-                      <a:endParaRPr lang="en-US" sz="800" b="0">
+                      <a:endParaRPr lang="en-US" sz="850" b="0">
                         <a:solidFill>
                           <a:schemeClr val="tx1"/>
                         </a:solidFill>
@@ -27773,7 +27907,7 @@
                   </a:ext>
                 </a:extLst>
               </a:tr>
-              <a:tr h="152236">
+              <a:tr h="0">
                 <a:tc>
                   <a:txBody>
                     <a:bodyPr/>
@@ -27783,7 +27917,7 @@
                         <a:buNone/>
                       </a:pPr>
                       <a:r>
-                        <a:rPr lang="en-US" sz="800" b="0" u="none" dirty="0">
+                        <a:rPr lang="en-US" sz="850" b="0" u="none" dirty="0">
                           <a:effectLst/>
                           <a:latin typeface="IBM Plex Mono Text" panose="020B0509050203000203" pitchFamily="49" charset="0"/>
                           <a:hlinkClick r:id="rId13" tooltip="#_regex_matches">
@@ -27796,7 +27930,7 @@
                         </a:rPr>
                         <a:t>REGEX_MATCHES</a:t>
                       </a:r>
-                      <a:endParaRPr lang="en-US" sz="800" b="0" u="none" dirty="0">
+                      <a:endParaRPr lang="en-US" sz="850" b="0" u="none" dirty="0">
                         <a:solidFill>
                           <a:schemeClr val="tx1"/>
                         </a:solidFill>
@@ -27816,13 +27950,13 @@
                         <a:buNone/>
                       </a:pPr>
                       <a:r>
-                        <a:rPr lang="en-US" sz="800">
+                        <a:rPr lang="en-US" sz="850">
                           <a:effectLst/>
                           <a:latin typeface="IBM Plex Sans Text" panose="020B0503050203000203" pitchFamily="34" charset="0"/>
                         </a:rPr>
                         <a:t>S</a:t>
                       </a:r>
-                      <a:endParaRPr lang="en-US" sz="800" b="0">
+                      <a:endParaRPr lang="en-US" sz="850" b="0">
                         <a:solidFill>
                           <a:schemeClr val="tx1"/>
                         </a:solidFill>
@@ -27842,13 +27976,13 @@
                         <a:buNone/>
                       </a:pPr>
                       <a:r>
-                        <a:rPr lang="en-US" sz="800">
+                        <a:rPr lang="en-US" sz="850">
                           <a:effectLst/>
                           <a:latin typeface="IBM Plex Sans Text" panose="020B0503050203000203" pitchFamily="34" charset="0"/>
                         </a:rPr>
                         <a:t>Strings</a:t>
                       </a:r>
-                      <a:endParaRPr lang="en-US" sz="800" b="0">
+                      <a:endParaRPr lang="en-US" sz="850" b="0">
                         <a:solidFill>
                           <a:schemeClr val="tx1"/>
                         </a:solidFill>
@@ -27868,13 +28002,13 @@
                         <a:buNone/>
                       </a:pPr>
                       <a:r>
-                        <a:rPr lang="en-US" sz="800" dirty="0">
+                        <a:rPr lang="en-US" sz="850" dirty="0">
                           <a:effectLst/>
                           <a:latin typeface="IBM Plex Sans Text" panose="020B0503050203000203" pitchFamily="34" charset="0"/>
                         </a:rPr>
                         <a:t>Matches a regular expression against a string.</a:t>
                       </a:r>
-                      <a:endParaRPr lang="en-US" sz="800" b="0" dirty="0">
+                      <a:endParaRPr lang="en-US" sz="850" b="0" dirty="0">
                         <a:solidFill>
                           <a:schemeClr val="tx1"/>
                         </a:solidFill>
@@ -27894,13 +28028,13 @@
                         <a:buNone/>
                       </a:pPr>
                       <a:r>
-                        <a:rPr lang="en-US" sz="800" dirty="0">
+                        <a:rPr lang="en-US" sz="850" dirty="0">
                           <a:effectLst/>
                           <a:latin typeface="IBM Plex Sans Text" panose="020B0503050203000203" pitchFamily="34" charset="0"/>
                         </a:rPr>
                         <a:t>Java or SQL</a:t>
                       </a:r>
-                      <a:endParaRPr lang="en-US" sz="800" b="0" dirty="0">
+                      <a:endParaRPr lang="en-US" sz="850" b="0" dirty="0">
                         <a:solidFill>
                           <a:schemeClr val="tx1"/>
                         </a:solidFill>
@@ -27917,7 +28051,7 @@
                   </a:ext>
                 </a:extLst>
               </a:tr>
-              <a:tr h="152236">
+              <a:tr h="0">
                 <a:tc>
                   <a:txBody>
                     <a:bodyPr/>
@@ -27927,7 +28061,7 @@
                         <a:buNone/>
                       </a:pPr>
                       <a:r>
-                        <a:rPr lang="en-US" sz="800" b="0" u="none" dirty="0">
+                        <a:rPr lang="en-US" sz="850" b="0" u="none" dirty="0">
                           <a:effectLst/>
                           <a:latin typeface="IBM Plex Mono Text" panose="020B0509050203000203" pitchFamily="49" charset="0"/>
                           <a:hlinkClick r:id="rId14" tooltip="#_regex_replace">
@@ -27940,7 +28074,7 @@
                         </a:rPr>
                         <a:t>REGEX_REPLACE</a:t>
                       </a:r>
-                      <a:endParaRPr lang="en-US" sz="800" b="0" u="none" dirty="0">
+                      <a:endParaRPr lang="en-US" sz="850" b="0" u="none" dirty="0">
                         <a:solidFill>
                           <a:schemeClr val="tx1"/>
                         </a:solidFill>
@@ -27960,13 +28094,13 @@
                         <a:buNone/>
                       </a:pPr>
                       <a:r>
-                        <a:rPr lang="en-US" sz="800">
+                        <a:rPr lang="en-US" sz="850">
                           <a:effectLst/>
                           <a:latin typeface="IBM Plex Sans Text" panose="020B0503050203000203" pitchFamily="34" charset="0"/>
                         </a:rPr>
                         <a:t>S</a:t>
                       </a:r>
-                      <a:endParaRPr lang="en-US" sz="800" b="0">
+                      <a:endParaRPr lang="en-US" sz="850" b="0">
                         <a:solidFill>
                           <a:schemeClr val="tx1"/>
                         </a:solidFill>
@@ -27986,13 +28120,13 @@
                         <a:buNone/>
                       </a:pPr>
                       <a:r>
-                        <a:rPr lang="en-US" sz="800">
+                        <a:rPr lang="en-US" sz="850">
                           <a:effectLst/>
                           <a:latin typeface="IBM Plex Sans Text" panose="020B0503050203000203" pitchFamily="34" charset="0"/>
                         </a:rPr>
                         <a:t>Strings</a:t>
                       </a:r>
-                      <a:endParaRPr lang="en-US" sz="800" b="0">
+                      <a:endParaRPr lang="en-US" sz="850" b="0">
                         <a:solidFill>
                           <a:schemeClr val="tx1"/>
                         </a:solidFill>
@@ -28012,13 +28146,13 @@
                         <a:buNone/>
                       </a:pPr>
                       <a:r>
-                        <a:rPr lang="en-US" sz="800" dirty="0">
+                        <a:rPr lang="en-US" sz="850" dirty="0">
                           <a:effectLst/>
                           <a:latin typeface="IBM Plex Sans Text" panose="020B0503050203000203" pitchFamily="34" charset="0"/>
                         </a:rPr>
                         <a:t>Replaces regular expression matches within a string.</a:t>
                       </a:r>
-                      <a:endParaRPr lang="en-US" sz="800" b="0" dirty="0">
+                      <a:endParaRPr lang="en-US" sz="850" b="0" dirty="0">
                         <a:solidFill>
                           <a:schemeClr val="tx1"/>
                         </a:solidFill>
@@ -28038,13 +28172,13 @@
                         <a:buNone/>
                       </a:pPr>
                       <a:r>
-                        <a:rPr lang="en-US" sz="800">
+                        <a:rPr lang="en-US" sz="850">
                           <a:effectLst/>
                           <a:latin typeface="IBM Plex Sans Text" panose="020B0503050203000203" pitchFamily="34" charset="0"/>
                         </a:rPr>
                         <a:t>Java</a:t>
                       </a:r>
-                      <a:endParaRPr lang="en-US" sz="800" b="0">
+                      <a:endParaRPr lang="en-US" sz="850" b="0">
                         <a:solidFill>
                           <a:schemeClr val="tx1"/>
                         </a:solidFill>
@@ -28061,7 +28195,7 @@
                   </a:ext>
                 </a:extLst>
               </a:tr>
-              <a:tr h="152236">
+              <a:tr h="0">
                 <a:tc>
                   <a:txBody>
                     <a:bodyPr/>
@@ -28071,7 +28205,7 @@
                         <a:buNone/>
                       </a:pPr>
                       <a:r>
-                        <a:rPr lang="en-US" sz="800" b="0" u="none" dirty="0">
+                        <a:rPr lang="en-US" sz="850" b="0" u="none" dirty="0">
                           <a:effectLst/>
                           <a:latin typeface="IBM Plex Mono Text" panose="020B0509050203000203" pitchFamily="49" charset="0"/>
                           <a:hlinkClick r:id="rId15" tooltip="#_runstats">
@@ -28084,7 +28218,7 @@
                         </a:rPr>
                         <a:t>RUNSTATS</a:t>
                       </a:r>
-                      <a:endParaRPr lang="en-US" sz="800" b="0" u="none" dirty="0">
+                      <a:endParaRPr lang="en-US" sz="850" b="0" u="none" dirty="0">
                         <a:solidFill>
                           <a:schemeClr val="tx1"/>
                         </a:solidFill>
@@ -28104,13 +28238,13 @@
                         <a:buNone/>
                       </a:pPr>
                       <a:r>
-                        <a:rPr lang="en-US" sz="800">
+                        <a:rPr lang="en-US" sz="850">
                           <a:effectLst/>
                           <a:latin typeface="IBM Plex Sans Text" panose="020B0503050203000203" pitchFamily="34" charset="0"/>
                         </a:rPr>
                         <a:t>S</a:t>
                       </a:r>
-                      <a:endParaRPr lang="en-US" sz="800" b="0">
+                      <a:endParaRPr lang="en-US" sz="850" b="0">
                         <a:solidFill>
                           <a:schemeClr val="tx1"/>
                         </a:solidFill>
@@ -28130,13 +28264,13 @@
                         <a:buNone/>
                       </a:pPr>
                       <a:r>
-                        <a:rPr lang="en-US" sz="800">
+                        <a:rPr lang="en-US" sz="850">
                           <a:effectLst/>
                           <a:latin typeface="IBM Plex Sans Text" panose="020B0503050203000203" pitchFamily="34" charset="0"/>
                         </a:rPr>
                         <a:t>Utilities</a:t>
                       </a:r>
-                      <a:endParaRPr lang="en-US" sz="800" b="0">
+                      <a:endParaRPr lang="en-US" sz="850" b="0">
                         <a:solidFill>
                           <a:schemeClr val="tx1"/>
                         </a:solidFill>
@@ -28156,13 +28290,13 @@
                         <a:buNone/>
                       </a:pPr>
                       <a:r>
-                        <a:rPr lang="en-US" sz="800" dirty="0">
+                        <a:rPr lang="en-US" sz="850" dirty="0">
                           <a:effectLst/>
                           <a:latin typeface="IBM Plex Sans Text" panose="020B0503050203000203" pitchFamily="34" charset="0"/>
                         </a:rPr>
                         <a:t>Runs statistics against a table or a set of tables.</a:t>
                       </a:r>
-                      <a:endParaRPr lang="en-US" sz="800" b="0" dirty="0">
+                      <a:endParaRPr lang="en-US" sz="850" b="0" dirty="0">
                         <a:solidFill>
                           <a:schemeClr val="tx1"/>
                         </a:solidFill>
@@ -28182,13 +28316,13 @@
                         <a:buNone/>
                       </a:pPr>
                       <a:r>
-                        <a:rPr lang="en-US" sz="800">
+                        <a:rPr lang="en-US" sz="850">
                           <a:effectLst/>
                           <a:latin typeface="IBM Plex Sans Text" panose="020B0503050203000203" pitchFamily="34" charset="0"/>
                         </a:rPr>
                         <a:t>SQL</a:t>
                       </a:r>
-                      <a:endParaRPr lang="en-US" sz="800" b="0">
+                      <a:endParaRPr lang="en-US" sz="850" b="0">
                         <a:solidFill>
                           <a:schemeClr val="tx1"/>
                         </a:solidFill>
@@ -28205,7 +28339,7 @@
                   </a:ext>
                 </a:extLst>
               </a:tr>
-              <a:tr h="152236">
+              <a:tr h="0">
                 <a:tc>
                   <a:txBody>
                     <a:bodyPr/>
@@ -28215,7 +28349,7 @@
                         <a:buNone/>
                       </a:pPr>
                       <a:r>
-                        <a:rPr lang="en-US" sz="800" b="0" u="none" dirty="0">
+                        <a:rPr lang="en-US" sz="850" b="0" u="none" dirty="0">
                           <a:effectLst/>
                           <a:latin typeface="IBM Plex Mono Text" panose="020B0509050203000203" pitchFamily="49" charset="0"/>
                           <a:hlinkClick r:id="rId16" tooltip="#_split">
@@ -28228,7 +28362,7 @@
                         </a:rPr>
                         <a:t>SPLIT</a:t>
                       </a:r>
-                      <a:endParaRPr lang="en-US" sz="800" b="0" u="none" dirty="0">
+                      <a:endParaRPr lang="en-US" sz="850" b="0" u="none" dirty="0">
                         <a:solidFill>
                           <a:schemeClr val="tx1"/>
                         </a:solidFill>
@@ -28248,13 +28382,13 @@
                         <a:buNone/>
                       </a:pPr>
                       <a:r>
-                        <a:rPr lang="en-US" sz="800">
+                        <a:rPr lang="en-US" sz="850">
                           <a:effectLst/>
                           <a:latin typeface="IBM Plex Sans Text" panose="020B0503050203000203" pitchFamily="34" charset="0"/>
                         </a:rPr>
                         <a:t>T</a:t>
                       </a:r>
-                      <a:endParaRPr lang="en-US" sz="800" b="0">
+                      <a:endParaRPr lang="en-US" sz="850" b="0">
                         <a:solidFill>
                           <a:schemeClr val="tx1"/>
                         </a:solidFill>
@@ -28274,13 +28408,13 @@
                         <a:buNone/>
                       </a:pPr>
                       <a:r>
-                        <a:rPr lang="en-US" sz="800">
+                        <a:rPr lang="en-US" sz="850">
                           <a:effectLst/>
                           <a:latin typeface="IBM Plex Sans Text" panose="020B0503050203000203" pitchFamily="34" charset="0"/>
                         </a:rPr>
                         <a:t>Text</a:t>
                       </a:r>
-                      <a:endParaRPr lang="en-US" sz="800" b="0">
+                      <a:endParaRPr lang="en-US" sz="850" b="0">
                         <a:solidFill>
                           <a:schemeClr val="tx1"/>
                         </a:solidFill>
@@ -28300,13 +28434,13 @@
                         <a:buNone/>
                       </a:pPr>
                       <a:r>
-                        <a:rPr lang="en-US" sz="800" dirty="0">
+                        <a:rPr lang="en-US" sz="850" dirty="0">
                           <a:effectLst/>
                           <a:latin typeface="IBM Plex Sans Text" panose="020B0503050203000203" pitchFamily="34" charset="0"/>
                         </a:rPr>
                         <a:t>Tokenizes a comma-separated string (inverse of LISTAGG).</a:t>
                       </a:r>
-                      <a:endParaRPr lang="en-US" sz="800" b="0" dirty="0">
+                      <a:endParaRPr lang="en-US" sz="850" b="0" dirty="0">
                         <a:solidFill>
                           <a:schemeClr val="tx1"/>
                         </a:solidFill>
@@ -28326,13 +28460,13 @@
                         <a:buNone/>
                       </a:pPr>
                       <a:r>
-                        <a:rPr lang="en-US" sz="800">
+                        <a:rPr lang="en-US" sz="850">
                           <a:effectLst/>
                           <a:latin typeface="IBM Plex Sans Text" panose="020B0503050203000203" pitchFamily="34" charset="0"/>
                         </a:rPr>
                         <a:t>SQL</a:t>
                       </a:r>
-                      <a:endParaRPr lang="en-US" sz="800" b="0">
+                      <a:endParaRPr lang="en-US" sz="850" b="0">
                         <a:solidFill>
                           <a:schemeClr val="tx1"/>
                         </a:solidFill>
@@ -28349,7 +28483,7 @@
                   </a:ext>
                 </a:extLst>
               </a:tr>
-              <a:tr h="152236">
+              <a:tr h="0">
                 <a:tc>
                   <a:txBody>
                     <a:bodyPr/>
@@ -28359,7 +28493,7 @@
                         <a:buNone/>
                       </a:pPr>
                       <a:r>
-                        <a:rPr lang="en-US" sz="800" b="0" u="none" dirty="0">
+                        <a:rPr lang="en-US" sz="850" b="0" u="none" dirty="0">
                           <a:effectLst/>
                           <a:latin typeface="IBM Plex Mono Text" panose="020B0509050203000203" pitchFamily="49" charset="0"/>
                           <a:hlinkClick r:id="rId17" tooltip="#_sprintf">
@@ -28372,7 +28506,7 @@
                         </a:rPr>
                         <a:t>SPRINTF</a:t>
                       </a:r>
-                      <a:endParaRPr lang="en-US" sz="800" b="0" u="none" dirty="0">
+                      <a:endParaRPr lang="en-US" sz="850" b="0" u="none" dirty="0">
                         <a:solidFill>
                           <a:schemeClr val="tx1"/>
                         </a:solidFill>
@@ -28392,13 +28526,13 @@
                         <a:buNone/>
                       </a:pPr>
                       <a:r>
-                        <a:rPr lang="en-US" sz="800">
+                        <a:rPr lang="en-US" sz="850">
                           <a:effectLst/>
                           <a:latin typeface="IBM Plex Sans Text" panose="020B0503050203000203" pitchFamily="34" charset="0"/>
                         </a:rPr>
                         <a:t>T</a:t>
                       </a:r>
-                      <a:endParaRPr lang="en-US" sz="800" b="0">
+                      <a:endParaRPr lang="en-US" sz="850" b="0">
                         <a:solidFill>
                           <a:schemeClr val="tx1"/>
                         </a:solidFill>
@@ -28418,13 +28552,13 @@
                         <a:buNone/>
                       </a:pPr>
                       <a:r>
-                        <a:rPr lang="en-US" sz="800">
+                        <a:rPr lang="en-US" sz="850">
                           <a:effectLst/>
                           <a:latin typeface="IBM Plex Sans Text" panose="020B0503050203000203" pitchFamily="34" charset="0"/>
                         </a:rPr>
                         <a:t>Text</a:t>
                       </a:r>
-                      <a:endParaRPr lang="en-US" sz="800" b="0">
+                      <a:endParaRPr lang="en-US" sz="850" b="0">
                         <a:solidFill>
                           <a:schemeClr val="tx1"/>
                         </a:solidFill>
@@ -28444,13 +28578,13 @@
                         <a:buNone/>
                       </a:pPr>
                       <a:r>
-                        <a:rPr lang="en-US" sz="800" dirty="0">
+                        <a:rPr lang="en-US" sz="850" dirty="0">
                           <a:effectLst/>
                           <a:latin typeface="IBM Plex Sans Text" panose="020B0503050203000203" pitchFamily="34" charset="0"/>
                         </a:rPr>
                         <a:t>Formats one or more values according to a Java-style format string.</a:t>
                       </a:r>
-                      <a:endParaRPr lang="en-US" sz="800" b="0" dirty="0">
+                      <a:endParaRPr lang="en-US" sz="850" b="0" dirty="0">
                         <a:solidFill>
                           <a:schemeClr val="tx1"/>
                         </a:solidFill>
@@ -28470,13 +28604,13 @@
                         <a:buNone/>
                       </a:pPr>
                       <a:r>
-                        <a:rPr lang="en-US" sz="800">
+                        <a:rPr lang="en-US" sz="850">
                           <a:effectLst/>
                           <a:latin typeface="IBM Plex Sans Text" panose="020B0503050203000203" pitchFamily="34" charset="0"/>
                         </a:rPr>
                         <a:t>Java</a:t>
                       </a:r>
-                      <a:endParaRPr lang="en-US" sz="800" b="0">
+                      <a:endParaRPr lang="en-US" sz="850" b="0">
                         <a:solidFill>
                           <a:schemeClr val="tx1"/>
                         </a:solidFill>
@@ -28493,7 +28627,7 @@
                   </a:ext>
                 </a:extLst>
               </a:tr>
-              <a:tr h="152236">
+              <a:tr h="0">
                 <a:tc>
                   <a:txBody>
                     <a:bodyPr/>
@@ -28503,7 +28637,7 @@
                         <a:buNone/>
                       </a:pPr>
                       <a:r>
-                        <a:rPr lang="en-US" sz="800" b="0" u="none" dirty="0">
+                        <a:rPr lang="en-US" sz="850" b="0" u="none" dirty="0">
                           <a:effectLst/>
                           <a:latin typeface="IBM Plex Mono Text" panose="020B0509050203000203" pitchFamily="49" charset="0"/>
                           <a:hlinkClick r:id="rId18" tooltip="#:submit">
@@ -28516,7 +28650,7 @@
                         </a:rPr>
                         <a:t>SUBMIT</a:t>
                       </a:r>
-                      <a:endParaRPr lang="en-US" sz="800" b="0" u="none" dirty="0">
+                      <a:endParaRPr lang="en-US" sz="850" b="0" u="none" dirty="0">
                         <a:solidFill>
                           <a:schemeClr val="tx1"/>
                         </a:solidFill>
@@ -28536,13 +28670,13 @@
                         <a:buNone/>
                       </a:pPr>
                       <a:r>
-                        <a:rPr lang="en-US" sz="800">
+                        <a:rPr lang="en-US" sz="850">
                           <a:effectLst/>
                           <a:latin typeface="IBM Plex Sans Text" panose="020B0503050203000203" pitchFamily="34" charset="0"/>
                         </a:rPr>
                         <a:t>S</a:t>
                       </a:r>
-                      <a:endParaRPr lang="en-US" sz="800" b="0">
+                      <a:endParaRPr lang="en-US" sz="850" b="0">
                         <a:solidFill>
                           <a:schemeClr val="tx1"/>
                         </a:solidFill>
@@ -28562,13 +28696,13 @@
                         <a:buNone/>
                       </a:pPr>
                       <a:r>
-                        <a:rPr lang="en-US" sz="800">
+                        <a:rPr lang="en-US" sz="850">
                           <a:effectLst/>
                           <a:latin typeface="IBM Plex Sans Text" panose="020B0503050203000203" pitchFamily="34" charset="0"/>
                         </a:rPr>
                         <a:t>Utilities</a:t>
                       </a:r>
-                      <a:endParaRPr lang="en-US" sz="800" b="0">
+                      <a:endParaRPr lang="en-US" sz="850" b="0">
                         <a:solidFill>
                           <a:schemeClr val="tx1"/>
                         </a:solidFill>
@@ -28588,13 +28722,13 @@
                         <a:buNone/>
                       </a:pPr>
                       <a:r>
-                        <a:rPr lang="en-US" sz="800" dirty="0">
+                        <a:rPr lang="en-US" sz="850" dirty="0">
                           <a:effectLst/>
                           <a:latin typeface="IBM Plex Sans Text" panose="020B0503050203000203" pitchFamily="34" charset="0"/>
                         </a:rPr>
                         <a:t>Submits a JCL job stream and returns the job output as a CLOB.</a:t>
                       </a:r>
-                      <a:endParaRPr lang="en-US" sz="800" b="0" dirty="0">
+                      <a:endParaRPr lang="en-US" sz="850" b="0" dirty="0">
                         <a:solidFill>
                           <a:schemeClr val="tx1"/>
                         </a:solidFill>
@@ -28614,13 +28748,13 @@
                         <a:buNone/>
                       </a:pPr>
                       <a:r>
-                        <a:rPr lang="en-US" sz="800">
+                        <a:rPr lang="en-US" sz="850">
                           <a:effectLst/>
                           <a:latin typeface="IBM Plex Sans Text" panose="020B0503050203000203" pitchFamily="34" charset="0"/>
                         </a:rPr>
                         <a:t>SQL</a:t>
                       </a:r>
-                      <a:endParaRPr lang="en-US" sz="800" b="0">
+                      <a:endParaRPr lang="en-US" sz="850" b="0">
                         <a:solidFill>
                           <a:schemeClr val="tx1"/>
                         </a:solidFill>
@@ -28637,7 +28771,7 @@
                   </a:ext>
                 </a:extLst>
               </a:tr>
-              <a:tr h="152236">
+              <a:tr h="0">
                 <a:tc>
                   <a:txBody>
                     <a:bodyPr/>
@@ -28647,7 +28781,7 @@
                         <a:buNone/>
                       </a:pPr>
                       <a:r>
-                        <a:rPr lang="en-US" sz="800" b="0" u="none" dirty="0">
+                        <a:rPr lang="en-US" sz="850" b="0" u="none" dirty="0">
                           <a:effectLst/>
                           <a:latin typeface="IBM Plex Mono Text" panose="020B0509050203000203" pitchFamily="49" charset="0"/>
                           <a:hlinkClick r:id="rId18" tooltip="#:submit">
@@ -28660,7 +28794,7 @@
                         </a:rPr>
                         <a:t>SUBMIT_T</a:t>
                       </a:r>
-                      <a:endParaRPr lang="en-US" sz="800" b="0" u="none" dirty="0">
+                      <a:endParaRPr lang="en-US" sz="850" b="0" u="none" dirty="0">
                         <a:solidFill>
                           <a:schemeClr val="tx1"/>
                         </a:solidFill>
@@ -28680,13 +28814,13 @@
                         <a:buNone/>
                       </a:pPr>
                       <a:r>
-                        <a:rPr lang="en-US" sz="800">
+                        <a:rPr lang="en-US" sz="850">
                           <a:effectLst/>
                           <a:latin typeface="IBM Plex Sans Text" panose="020B0503050203000203" pitchFamily="34" charset="0"/>
                         </a:rPr>
                         <a:t>T</a:t>
                       </a:r>
-                      <a:endParaRPr lang="en-US" sz="800" b="0">
+                      <a:endParaRPr lang="en-US" sz="850" b="0">
                         <a:solidFill>
                           <a:schemeClr val="tx1"/>
                         </a:solidFill>
@@ -28706,13 +28840,13 @@
                         <a:buNone/>
                       </a:pPr>
                       <a:r>
-                        <a:rPr lang="en-US" sz="800">
+                        <a:rPr lang="en-US" sz="850">
                           <a:effectLst/>
                           <a:latin typeface="IBM Plex Sans Text" panose="020B0503050203000203" pitchFamily="34" charset="0"/>
                         </a:rPr>
                         <a:t>Utilities</a:t>
                       </a:r>
-                      <a:endParaRPr lang="en-US" sz="800" b="0">
+                      <a:endParaRPr lang="en-US" sz="850" b="0">
                         <a:solidFill>
                           <a:schemeClr val="tx1"/>
                         </a:solidFill>
@@ -28732,13 +28866,13 @@
                         <a:buNone/>
                       </a:pPr>
                       <a:r>
-                        <a:rPr lang="en-US" sz="800" dirty="0">
+                        <a:rPr lang="en-US" sz="850" dirty="0">
                           <a:effectLst/>
                           <a:latin typeface="IBM Plex Sans Text" panose="020B0503050203000203" pitchFamily="34" charset="0"/>
                         </a:rPr>
                         <a:t>Submits a JCL job stream and returns the job output as a table.</a:t>
                       </a:r>
-                      <a:endParaRPr lang="en-US" sz="800" b="0" dirty="0">
+                      <a:endParaRPr lang="en-US" sz="850" b="0" dirty="0">
                         <a:solidFill>
                           <a:schemeClr val="tx1"/>
                         </a:solidFill>
@@ -28758,13 +28892,13 @@
                         <a:buNone/>
                       </a:pPr>
                       <a:r>
-                        <a:rPr lang="en-US" sz="800">
+                        <a:rPr lang="en-US" sz="850">
                           <a:effectLst/>
                           <a:latin typeface="IBM Plex Sans Text" panose="020B0503050203000203" pitchFamily="34" charset="0"/>
                         </a:rPr>
                         <a:t>SQL</a:t>
                       </a:r>
-                      <a:endParaRPr lang="en-US" sz="800" b="0">
+                      <a:endParaRPr lang="en-US" sz="850" b="0">
                         <a:solidFill>
                           <a:schemeClr val="tx1"/>
                         </a:solidFill>
@@ -28781,7 +28915,7 @@
                   </a:ext>
                 </a:extLst>
               </a:tr>
-              <a:tr h="152236">
+              <a:tr h="0">
                 <a:tc>
                   <a:txBody>
                     <a:bodyPr/>
@@ -28791,7 +28925,7 @@
                         <a:buNone/>
                       </a:pPr>
                       <a:r>
-                        <a:rPr lang="en-US" sz="800" b="0" u="none" dirty="0">
+                        <a:rPr lang="en-US" sz="850" b="0" u="none" dirty="0">
                           <a:effectLst/>
                           <a:latin typeface="IBM Plex Mono Text" panose="020B0509050203000203" pitchFamily="49" charset="0"/>
                           <a:hlinkClick r:id="rId19" tooltip="#_to_roman">
@@ -28804,7 +28938,7 @@
                         </a:rPr>
                         <a:t>TO_ROMAN</a:t>
                       </a:r>
-                      <a:endParaRPr lang="en-US" sz="800" b="0" u="none" dirty="0">
+                      <a:endParaRPr lang="en-US" sz="850" b="0" u="none" dirty="0">
                         <a:solidFill>
                           <a:schemeClr val="tx1"/>
                         </a:solidFill>
@@ -28824,13 +28958,13 @@
                         <a:buNone/>
                       </a:pPr>
                       <a:r>
-                        <a:rPr lang="en-US" sz="800">
+                        <a:rPr lang="en-US" sz="850">
                           <a:effectLst/>
                           <a:latin typeface="IBM Plex Sans Text" panose="020B0503050203000203" pitchFamily="34" charset="0"/>
                         </a:rPr>
                         <a:t>S</a:t>
                       </a:r>
-                      <a:endParaRPr lang="en-US" sz="800" b="0">
+                      <a:endParaRPr lang="en-US" sz="850" b="0">
                         <a:solidFill>
                           <a:schemeClr val="tx1"/>
                         </a:solidFill>
@@ -28850,13 +28984,13 @@
                         <a:buNone/>
                       </a:pPr>
                       <a:r>
-                        <a:rPr lang="en-US" sz="800" dirty="0">
+                        <a:rPr lang="en-US" sz="850" dirty="0">
                           <a:effectLst/>
                           <a:latin typeface="IBM Plex Sans Text" panose="020B0503050203000203" pitchFamily="34" charset="0"/>
                         </a:rPr>
                         <a:t>Data types</a:t>
                       </a:r>
-                      <a:endParaRPr lang="en-US" sz="800" b="0" dirty="0">
+                      <a:endParaRPr lang="en-US" sz="850" b="0" dirty="0">
                         <a:solidFill>
                           <a:schemeClr val="tx1"/>
                         </a:solidFill>
@@ -28876,13 +29010,13 @@
                         <a:buNone/>
                       </a:pPr>
                       <a:r>
-                        <a:rPr lang="en-US" sz="800" dirty="0">
+                        <a:rPr lang="en-US" sz="850" dirty="0">
                           <a:effectLst/>
                           <a:latin typeface="IBM Plex Sans Text" panose="020B0503050203000203" pitchFamily="34" charset="0"/>
                         </a:rPr>
                         <a:t>Converts a small integer to a Roman numeral.</a:t>
                       </a:r>
-                      <a:endParaRPr lang="en-US" sz="800" b="0" dirty="0">
+                      <a:endParaRPr lang="en-US" sz="850" b="0" dirty="0">
                         <a:solidFill>
                           <a:schemeClr val="tx1"/>
                         </a:solidFill>
@@ -28902,13 +29036,13 @@
                         <a:buNone/>
                       </a:pPr>
                       <a:r>
-                        <a:rPr lang="en-US" sz="800">
+                        <a:rPr lang="en-US" sz="850">
                           <a:effectLst/>
                           <a:latin typeface="IBM Plex Sans Text" panose="020B0503050203000203" pitchFamily="34" charset="0"/>
                         </a:rPr>
                         <a:t>SQL</a:t>
                       </a:r>
-                      <a:endParaRPr lang="en-US" sz="800" b="0">
+                      <a:endParaRPr lang="en-US" sz="850" b="0">
                         <a:solidFill>
                           <a:schemeClr val="tx1"/>
                         </a:solidFill>
@@ -28925,7 +29059,7 @@
                   </a:ext>
                 </a:extLst>
               </a:tr>
-              <a:tr h="354676">
+              <a:tr h="0">
                 <a:tc>
                   <a:txBody>
                     <a:bodyPr/>
@@ -28935,7 +29069,7 @@
                         <a:buNone/>
                       </a:pPr>
                       <a:r>
-                        <a:rPr lang="en-US" sz="800" b="0" u="none" dirty="0">
+                        <a:rPr lang="en-US" sz="850" b="0" u="none" dirty="0">
                           <a:effectLst/>
                           <a:latin typeface="IBM Plex Mono Text" panose="020B0509050203000203" pitchFamily="49" charset="0"/>
                           <a:hlinkClick r:id="rId20" tooltip="#:try_integer">
@@ -28949,7 +29083,7 @@
                         <a:t>TRY_INTEGER, TRY_SMALLINT,</a:t>
                       </a:r>
                       <a:br>
-                        <a:rPr lang="en-US" sz="800" b="0" u="none" dirty="0">
+                        <a:rPr lang="en-US" sz="850" b="0" u="none" dirty="0">
                           <a:effectLst/>
                           <a:latin typeface="IBM Plex Mono Text" panose="020B0509050203000203" pitchFamily="49" charset="0"/>
                           <a:hlinkClick r:id="rId20" tooltip="#:try_integer">
@@ -28962,7 +29096,7 @@
                         </a:rPr>
                       </a:br>
                       <a:r>
-                        <a:rPr lang="en-US" sz="800" b="0" u="none" dirty="0">
+                        <a:rPr lang="en-US" sz="850" b="0" u="none" dirty="0">
                           <a:effectLst/>
                           <a:latin typeface="IBM Plex Mono Text" panose="020B0509050203000203" pitchFamily="49" charset="0"/>
                           <a:hlinkClick r:id="rId20" tooltip="#:try_integer">
@@ -28975,7 +29109,7 @@
                         </a:rPr>
                         <a:t>TRY_BIGINT</a:t>
                       </a:r>
-                      <a:endParaRPr lang="en-US" sz="800" b="0" u="none" dirty="0">
+                      <a:endParaRPr lang="en-US" sz="850" b="0" u="none" dirty="0">
                         <a:solidFill>
                           <a:schemeClr val="tx1"/>
                         </a:solidFill>
@@ -28995,13 +29129,13 @@
                         <a:buNone/>
                       </a:pPr>
                       <a:r>
-                        <a:rPr lang="en-US" sz="800" dirty="0">
+                        <a:rPr lang="en-US" sz="850" dirty="0">
                           <a:effectLst/>
                           <a:latin typeface="IBM Plex Sans Text" panose="020B0503050203000203" pitchFamily="34" charset="0"/>
                         </a:rPr>
                         <a:t>S</a:t>
                       </a:r>
-                      <a:endParaRPr lang="en-US" sz="800" b="0" dirty="0">
+                      <a:endParaRPr lang="en-US" sz="850" b="0" dirty="0">
                         <a:solidFill>
                           <a:schemeClr val="tx1"/>
                         </a:solidFill>
@@ -29021,13 +29155,13 @@
                         <a:buNone/>
                       </a:pPr>
                       <a:r>
-                        <a:rPr lang="en-US" sz="800" dirty="0">
+                        <a:rPr lang="en-US" sz="850" dirty="0">
                           <a:effectLst/>
                           <a:latin typeface="IBM Plex Sans Text" panose="020B0503050203000203" pitchFamily="34" charset="0"/>
                         </a:rPr>
                         <a:t>Data types</a:t>
                       </a:r>
-                      <a:endParaRPr lang="en-US" sz="800" b="0" dirty="0">
+                      <a:endParaRPr lang="en-US" sz="850" b="0" dirty="0">
                         <a:solidFill>
                           <a:schemeClr val="tx1"/>
                         </a:solidFill>
@@ -29047,13 +29181,13 @@
                         <a:buNone/>
                       </a:pPr>
                       <a:r>
-                        <a:rPr lang="en-US" sz="800" dirty="0">
+                        <a:rPr lang="en-US" sz="850" dirty="0">
                           <a:effectLst/>
                           <a:latin typeface="IBM Plex Sans Text" panose="020B0503050203000203" pitchFamily="34" charset="0"/>
                         </a:rPr>
                         <a:t>Returns text converted to an integer or NULL on failure.</a:t>
                       </a:r>
-                      <a:endParaRPr lang="en-US" sz="800" b="0" dirty="0">
+                      <a:endParaRPr lang="en-US" sz="850" b="0" dirty="0">
                         <a:solidFill>
                           <a:schemeClr val="tx1"/>
                         </a:solidFill>
@@ -29073,13 +29207,13 @@
                         <a:buNone/>
                       </a:pPr>
                       <a:r>
-                        <a:rPr lang="en-US" sz="800" dirty="0">
+                        <a:rPr lang="en-US" sz="850" dirty="0">
                           <a:effectLst/>
                           <a:latin typeface="IBM Plex Sans Text" panose="020B0503050203000203" pitchFamily="34" charset="0"/>
                         </a:rPr>
                         <a:t>SQL</a:t>
                       </a:r>
-                      <a:endParaRPr lang="en-US" sz="800" b="0" dirty="0">
+                      <a:endParaRPr lang="en-US" sz="850" b="0" dirty="0">
                         <a:solidFill>
                           <a:schemeClr val="tx1"/>
                         </a:solidFill>
@@ -29096,7 +29230,7 @@
                   </a:ext>
                 </a:extLst>
               </a:tr>
-              <a:tr h="234685">
+              <a:tr h="0">
                 <a:tc>
                   <a:txBody>
                     <a:bodyPr/>
@@ -29106,7 +29240,7 @@
                         <a:buNone/>
                       </a:pPr>
                       <a:r>
-                        <a:rPr lang="en-US" sz="800" b="0" u="none" dirty="0">
+                        <a:rPr lang="en-US" sz="850" b="0" u="none" dirty="0">
                           <a:effectLst/>
                           <a:latin typeface="IBM Plex Mono Text" panose="020B0509050203000203" pitchFamily="49" charset="0"/>
                           <a:hlinkClick r:id="rId21" tooltip="#_validate_conversion">
@@ -29119,7 +29253,7 @@
                         </a:rPr>
                         <a:t>VALIDATE_CONVERSION</a:t>
                       </a:r>
-                      <a:endParaRPr lang="en-US" sz="800" b="0" u="none" dirty="0">
+                      <a:endParaRPr lang="en-US" sz="850" b="0" u="none" dirty="0">
                         <a:solidFill>
                           <a:schemeClr val="tx1"/>
                         </a:solidFill>
@@ -29139,13 +29273,13 @@
                         <a:buNone/>
                       </a:pPr>
                       <a:r>
-                        <a:rPr lang="en-US" sz="800">
+                        <a:rPr lang="en-US" sz="850">
                           <a:effectLst/>
                           <a:latin typeface="IBM Plex Sans Text" panose="020B0503050203000203" pitchFamily="34" charset="0"/>
                         </a:rPr>
                         <a:t>T</a:t>
                       </a:r>
-                      <a:endParaRPr lang="en-US" sz="800" b="0">
+                      <a:endParaRPr lang="en-US" sz="850" b="0">
                         <a:solidFill>
                           <a:schemeClr val="tx1"/>
                         </a:solidFill>
@@ -29165,13 +29299,13 @@
                         <a:buNone/>
                       </a:pPr>
                       <a:r>
-                        <a:rPr lang="en-US" sz="800" dirty="0">
+                        <a:rPr lang="en-US" sz="850" dirty="0">
                           <a:effectLst/>
                           <a:latin typeface="IBM Plex Sans Text" panose="020B0503050203000203" pitchFamily="34" charset="0"/>
                         </a:rPr>
                         <a:t>Data types</a:t>
                       </a:r>
-                      <a:endParaRPr lang="en-US" sz="800" b="0" dirty="0">
+                      <a:endParaRPr lang="en-US" sz="850" b="0" dirty="0">
                         <a:solidFill>
                           <a:schemeClr val="tx1"/>
                         </a:solidFill>
@@ -29191,13 +29325,13 @@
                         <a:buNone/>
                       </a:pPr>
                       <a:r>
-                        <a:rPr lang="en-US" sz="800" dirty="0">
+                        <a:rPr lang="en-US" sz="850" dirty="0">
                           <a:effectLst/>
                           <a:latin typeface="IBM Plex Sans Text" panose="020B0503050203000203" pitchFamily="34" charset="0"/>
                         </a:rPr>
                         <a:t>Tests whether a given string can be converted to a specified target type.</a:t>
                       </a:r>
-                      <a:endParaRPr lang="en-US" sz="800" b="0" dirty="0">
+                      <a:endParaRPr lang="en-US" sz="850" b="0" dirty="0">
                         <a:solidFill>
                           <a:schemeClr val="tx1"/>
                         </a:solidFill>
@@ -29217,13 +29351,13 @@
                         <a:buNone/>
                       </a:pPr>
                       <a:r>
-                        <a:rPr lang="en-US" sz="800" dirty="0">
+                        <a:rPr lang="en-US" sz="850" dirty="0">
                           <a:effectLst/>
                           <a:latin typeface="IBM Plex Sans Text" panose="020B0503050203000203" pitchFamily="34" charset="0"/>
                         </a:rPr>
                         <a:t>SQL</a:t>
                       </a:r>
-                      <a:endParaRPr lang="en-US" sz="800" b="0" dirty="0">
+                      <a:endParaRPr lang="en-US" sz="850" b="0" dirty="0">
                         <a:solidFill>
                           <a:schemeClr val="tx1"/>
                         </a:solidFill>
@@ -29240,7 +29374,7 @@
                   </a:ext>
                 </a:extLst>
               </a:tr>
-              <a:tr h="234685">
+              <a:tr h="0">
                 <a:tc>
                   <a:txBody>
                     <a:bodyPr/>
@@ -29250,7 +29384,7 @@
                         <a:buNone/>
                       </a:pPr>
                       <a:r>
-                        <a:rPr lang="en-US" sz="800" b="0" u="none" dirty="0">
+                        <a:rPr lang="en-US" sz="850" b="0" u="none" dirty="0">
                           <a:solidFill>
                             <a:schemeClr val="tx1"/>
                           </a:solidFill>
@@ -29272,7 +29406,7 @@
                         <a:buNone/>
                       </a:pPr>
                       <a:r>
-                        <a:rPr lang="en-US" sz="800" b="0" i="0" u="none" strike="noStrike" cap="none" spc="0" baseline="0" dirty="0">
+                        <a:rPr lang="en-US" sz="850" b="0" i="0" u="none" strike="noStrike" cap="none" spc="0" baseline="0" dirty="0">
                           <a:solidFill>
                             <a:schemeClr val="tx1"/>
                           </a:solidFill>
@@ -29298,7 +29432,7 @@
                         <a:buNone/>
                       </a:pPr>
                       <a:r>
-                        <a:rPr lang="en-US" sz="800" b="0" i="0" u="none" strike="noStrike" cap="none" spc="0" baseline="0" dirty="0">
+                        <a:rPr lang="en-US" sz="850" b="0" i="0" u="none" strike="noStrike" cap="none" spc="0" baseline="0" dirty="0">
                           <a:solidFill>
                             <a:schemeClr val="tx1"/>
                           </a:solidFill>
@@ -29324,7 +29458,7 @@
                         <a:buNone/>
                       </a:pPr>
                       <a:r>
-                        <a:rPr lang="en-US" sz="800" b="0" i="0" u="none" strike="noStrike" cap="none" spc="0" baseline="0" dirty="0">
+                        <a:rPr lang="en-US" sz="850" b="0" i="0" u="none" strike="noStrike" cap="none" spc="0" baseline="0" dirty="0">
                           <a:solidFill>
                             <a:schemeClr val="tx1"/>
                           </a:solidFill>
@@ -29350,7 +29484,7 @@
                         <a:buNone/>
                       </a:pPr>
                       <a:r>
-                        <a:rPr lang="en-US" sz="800" b="0" i="0" u="none" strike="noStrike" cap="none" spc="0" baseline="0" dirty="0">
+                        <a:rPr lang="en-US" sz="850" b="0" i="0" u="none" strike="noStrike" cap="none" spc="0" baseline="0" dirty="0">
                           <a:solidFill>
                             <a:schemeClr val="tx1"/>
                           </a:solidFill>

</xml_diff>

<commit_message>
docs: update regex documentation and add performance examples
</commit_message>
<xml_diff>
--- a/Db2 Routines Presentation.pptx
+++ b/Db2 Routines Presentation.pptx
@@ -24296,7 +24296,7 @@
               <a:rPr lang="en-US" sz="1000" dirty="0">
                 <a:latin typeface="IBM Plex Mono Text" panose="020B0509050203000203" pitchFamily="49" charset="0"/>
               </a:rPr>
-              <a:t>('TABLES', 'DSN81310', '^(EMP|DEPT)$', '') </a:t>
+              <a:t>('TABLES', 'DSN81310', ‘EMP%', '') </a:t>
             </a:r>
           </a:p>
           <a:p>
@@ -24688,7 +24688,7 @@
               <a:rPr lang="en-US" sz="1000" kern="0" dirty="0">
                 <a:latin typeface="IBM Plex Mono Text" panose="020B0509050203000203" pitchFamily="49" charset="0"/>
               </a:rPr>
-              <a:t>DSNU000I    162 04:01:04.66 DSNUGUTC - OUTPUT START FOR UTILITY, UTILID = UTIL35625</a:t>
+              <a:t>DSNU000I    166 18:17:55.80 DSNUGUTC - OUTPUT START FOR UTILITY, UTILID = UTIL08885</a:t>
             </a:r>
           </a:p>
           <a:p>
@@ -24701,7 +24701,7 @@
               <a:rPr lang="en-US" sz="1000" kern="0" dirty="0">
                 <a:latin typeface="IBM Plex Mono Text" panose="020B0509050203000203" pitchFamily="49" charset="0"/>
               </a:rPr>
-              <a:t>DSNU1045I   162 04:01:04.67 DSNUGTIS - PROCESSING SYSIN AS UNICODE UTF-8 </a:t>
+              <a:t>DSNU1045I   166 18:17:55.82 DSNUGTIS - PROCESSING SYSIN AS UNICODE UTF-8 </a:t>
             </a:r>
           </a:p>
           <a:p>
@@ -24714,7 +24714,7 @@
               <a:rPr lang="en-US" sz="1000" kern="0" dirty="0">
                 <a:latin typeface="IBM Plex Mono Text" panose="020B0509050203000203" pitchFamily="49" charset="0"/>
               </a:rPr>
-              <a:t>DSNU050I    162 04:01:04.68 DSNUGUTC -  LISTDEF RSLIST INCLUDE TABLE DSN81310."DEPT" INCLUDE TABLE DSN81310."EMP"</a:t>
+              <a:t>DSNU050I    166 18:17:55.84 DSNUGUTC -  LISTDEF RSLIST INCLUDE TABLE DSN81310."EMP" INCLUDE TABLE </a:t>
             </a:r>
           </a:p>
           <a:p>
@@ -24727,7 +24727,7 @@
               <a:rPr lang="en-US" sz="1000" kern="0" dirty="0">
                 <a:latin typeface="IBM Plex Mono Text" panose="020B0509050203000203" pitchFamily="49" charset="0"/>
               </a:rPr>
-              <a:t>DSNU1035I   162 04:01:04.69 DSNUILDR - LISTDEF STATEMENT PROCESSED SUCCESSFULLY</a:t>
+              <a:t>DSN81310."EMPPROJACT" INCLUDE TABLE DSN81310."EMP_PHOTO_RESUME"</a:t>
             </a:r>
           </a:p>
           <a:p>
@@ -24740,7 +24740,7 @@
               <a:rPr lang="en-US" sz="1000" kern="0" dirty="0">
                 <a:latin typeface="IBM Plex Mono Text" panose="020B0509050203000203" pitchFamily="49" charset="0"/>
               </a:rPr>
-              <a:t>DSNU050I    162 04:01:04.69 DSNUGUTC -  RUNSTATS TABLESPACE LIST RSLIST TABLE USE PROFILE SORTDEVT SYSALLDA</a:t>
+              <a:t>...</a:t>
             </a:r>
           </a:p>
           <a:p>
@@ -24750,11 +24750,14 @@
               </a:lnSpc>
             </a:pPr>
             <a:r>
-              <a:rPr lang="en-US" sz="1000" kern="0" dirty="0">
+              <a:rPr lang="en-US" sz="1000" kern="0">
                 <a:latin typeface="IBM Plex Mono Text" panose="020B0509050203000203" pitchFamily="49" charset="0"/>
               </a:rPr>
-              <a:t>…</a:t>
-            </a:r>
+              <a:t>DSNU010I    166 18:17:59.12 DSNUGBAC - UTILITY EXECUTION COMPLETE, HIGHEST RETURN CODE=0 </a:t>
+            </a:r>
+            <a:endParaRPr lang="en-US" sz="1000" kern="0" dirty="0">
+              <a:latin typeface="IBM Plex Mono Text" panose="020B0509050203000203" pitchFamily="49" charset="0"/>
+            </a:endParaRPr>
           </a:p>
         </p:txBody>
       </p:sp>
@@ -25940,14 +25943,14 @@
           <p:nvPr>
             <p:extLst>
               <p:ext uri="{D42A27DB-BD31-4B8C-83A1-F6EECF244321}">
-                <p14:modId xmlns:p14="http://schemas.microsoft.com/office/powerpoint/2010/main" val="3840208222"/>
+                <p14:modId xmlns:p14="http://schemas.microsoft.com/office/powerpoint/2010/main" val="4044563120"/>
               </p:ext>
             </p:extLst>
           </p:nvPr>
         </p:nvGraphicFramePr>
         <p:xfrm>
           <a:off x="215999" y="660816"/>
-          <a:ext cx="8583798" cy="3916020"/>
+          <a:ext cx="8583798" cy="3635060"/>
         </p:xfrm>
         <a:graphic>
           <a:graphicData uri="http://schemas.openxmlformats.org/drawingml/2006/table">
@@ -26167,13 +26170,6 @@
                         <a:rPr lang="en-US" sz="850" b="0" u="none" dirty="0">
                           <a:effectLst/>
                           <a:latin typeface="IBM Plex Mono Text" panose="020B0509050203000203" pitchFamily="49" charset="0"/>
-                          <a:hlinkClick r:id="rId2" tooltip="#_apflist">
-                            <a:extLst>
-                              <a:ext uri="{A12FA001-AC4F-418D-AE19-62706E023703}">
-                                <ahyp:hlinkClr xmlns:ahyp="http://schemas.microsoft.com/office/drawing/2018/hyperlinkcolor" val="tx"/>
-                              </a:ext>
-                            </a:extLst>
-                          </a:hlinkClick>
                         </a:rPr>
                         <a:t>APFLIST</a:t>
                       </a:r>
@@ -26331,27 +26327,9 @@
                           <a:ea typeface="+mn-ea"/>
                           <a:cs typeface="+mn-cs"/>
                           <a:sym typeface="IBM Plex Sans"/>
-                          <a:hlinkClick r:id="rId3" tooltip="#_base64decode">
-                            <a:extLst>
-                              <a:ext uri="{A12FA001-AC4F-418D-AE19-62706E023703}">
-                                <ahyp:hlinkClr xmlns:ahyp="http://schemas.microsoft.com/office/drawing/2018/hyperlinkcolor" val="tx"/>
-                              </a:ext>
-                            </a:extLst>
-                          </a:hlinkClick>
-                        </a:rPr>
-                        <a:t>BASE64DECODE</a:t>
-                      </a:r>
-                      <a:endParaRPr lang="en-US" sz="850" b="0" i="0" u="none" strike="noStrike" cap="none" spc="0" baseline="0" dirty="0">
-                        <a:solidFill>
-                          <a:schemeClr val="tx1"/>
-                        </a:solidFill>
-                        <a:effectLst/>
-                        <a:uFillTx/>
-                        <a:latin typeface="IBM Plex Mono Text" panose="020B0509050203000203" pitchFamily="49" charset="0"/>
-                        <a:ea typeface="+mn-ea"/>
-                        <a:cs typeface="+mn-cs"/>
-                        <a:sym typeface="IBM Plex Sans"/>
-                      </a:endParaRPr>
+                        </a:rPr>
+                        <a:t>BASE64ENCODE, BASE64DECODE</a:t>
+                      </a:r>
                     </a:p>
                   </a:txBody>
                   <a:tcPr marL="21880" marR="21880" marT="10940" marB="10940"/>
@@ -26421,7 +26399,7 @@
                           <a:effectLst/>
                           <a:latin typeface="IBM Plex Sans Text" panose="020B0503050203000203" pitchFamily="34" charset="0"/>
                         </a:rPr>
-                        <a:t>Decodes BASE64 format to binary data.</a:t>
+                        <a:t>Encodes binary data to BASE64 and vice versa.</a:t>
                       </a:r>
                       <a:endParaRPr lang="en-US" sz="850" b="0" dirty="0">
                         <a:solidFill>
@@ -26479,15 +26457,8 @@
                         <a:rPr lang="en-US" sz="850" b="0" u="none" dirty="0">
                           <a:effectLst/>
                           <a:latin typeface="IBM Plex Mono Text" panose="020B0509050203000203" pitchFamily="49" charset="0"/>
-                          <a:hlinkClick r:id="rId4" tooltip="#_base64encode">
-                            <a:extLst>
-                              <a:ext uri="{A12FA001-AC4F-418D-AE19-62706E023703}">
-                                <ahyp:hlinkClr xmlns:ahyp="http://schemas.microsoft.com/office/drawing/2018/hyperlinkcolor" val="tx"/>
-                              </a:ext>
-                            </a:extLst>
-                          </a:hlinkClick>
-                        </a:rPr>
-                        <a:t>BASE64ENCODE</a:t>
+                        </a:rPr>
+                        <a:t>CROSSLOAD</a:t>
                       </a:r>
                       <a:endParaRPr lang="en-US" sz="850" b="0" u="none" dirty="0">
                         <a:solidFill>
@@ -26539,7 +26510,7 @@
                           <a:effectLst/>
                           <a:latin typeface="IBM Plex Sans Text" panose="020B0503050203000203" pitchFamily="34" charset="0"/>
                         </a:rPr>
-                        <a:t>Data types</a:t>
+                        <a:t>Utilities</a:t>
                       </a:r>
                       <a:endParaRPr lang="en-US" sz="850" b="0" dirty="0">
                         <a:solidFill>
@@ -26565,7 +26536,7 @@
                           <a:effectLst/>
                           <a:latin typeface="IBM Plex Sans Text" panose="020B0503050203000203" pitchFamily="34" charset="0"/>
                         </a:rPr>
-                        <a:t>Encodes binary data to BASE64 format.</a:t>
+                        <a:t>Copies data from one table to another.</a:t>
                       </a:r>
                       <a:endParaRPr lang="en-US" sz="850" b="0" dirty="0">
                         <a:solidFill>
@@ -26587,157 +26558,13 @@
                         <a:buNone/>
                       </a:pPr>
                       <a:r>
-                        <a:rPr lang="en-US" sz="850">
-                          <a:effectLst/>
-                          <a:latin typeface="IBM Plex Sans Text" panose="020B0503050203000203" pitchFamily="34" charset="0"/>
-                        </a:rPr>
-                        <a:t>Java</a:t>
-                      </a:r>
-                      <a:endParaRPr lang="en-US" sz="850" b="0">
-                        <a:solidFill>
-                          <a:schemeClr val="tx1"/>
-                        </a:solidFill>
-                        <a:effectLst/>
-                        <a:latin typeface="IBM Plex Sans Text" panose="020B0503050203000203" pitchFamily="34" charset="0"/>
-                      </a:endParaRPr>
-                    </a:p>
-                  </a:txBody>
-                  <a:tcPr marL="21880" marR="21880" marT="10940" marB="10940"/>
-                </a:tc>
-                <a:extLst>
-                  <a:ext uri="{0D108BD9-81ED-4DB2-BD59-A6C34878D82A}">
-                    <a16:rowId xmlns:a16="http://schemas.microsoft.com/office/drawing/2014/main" val="2474946263"/>
-                  </a:ext>
-                </a:extLst>
-              </a:tr>
-              <a:tr h="0">
-                <a:tc>
-                  <a:txBody>
-                    <a:bodyPr/>
-                    <a:lstStyle/>
-                    <a:p>
-                      <a:pPr algn="l" rtl="0" fontAlgn="t">
-                        <a:buNone/>
-                      </a:pPr>
-                      <a:r>
-                        <a:rPr lang="en-US" sz="850" b="0" u="none" dirty="0">
-                          <a:effectLst/>
-                          <a:latin typeface="IBM Plex Mono Text" panose="020B0509050203000203" pitchFamily="49" charset="0"/>
-                          <a:hlinkClick r:id="rId5" tooltip="#_crossload">
-                            <a:extLst>
-                              <a:ext uri="{A12FA001-AC4F-418D-AE19-62706E023703}">
-                                <ahyp:hlinkClr xmlns:ahyp="http://schemas.microsoft.com/office/drawing/2018/hyperlinkcolor" val="tx"/>
-                              </a:ext>
-                            </a:extLst>
-                          </a:hlinkClick>
-                        </a:rPr>
-                        <a:t>CROSSLOAD</a:t>
-                      </a:r>
-                      <a:endParaRPr lang="en-US" sz="850" b="0" u="none" dirty="0">
-                        <a:solidFill>
-                          <a:schemeClr val="tx1"/>
-                        </a:solidFill>
-                        <a:effectLst/>
-                        <a:latin typeface="IBM Plex Mono Text" panose="020B0509050203000203" pitchFamily="49" charset="0"/>
-                      </a:endParaRPr>
-                    </a:p>
-                  </a:txBody>
-                  <a:tcPr marL="21880" marR="21880" marT="10940" marB="10940"/>
-                </a:tc>
-                <a:tc>
-                  <a:txBody>
-                    <a:bodyPr/>
-                    <a:lstStyle/>
-                    <a:p>
-                      <a:pPr algn="l" rtl="0" fontAlgn="t">
-                        <a:buNone/>
-                      </a:pPr>
-                      <a:r>
-                        <a:rPr lang="en-US" sz="850">
-                          <a:effectLst/>
-                          <a:latin typeface="IBM Plex Sans Text" panose="020B0503050203000203" pitchFamily="34" charset="0"/>
-                        </a:rPr>
-                        <a:t>S</a:t>
-                      </a:r>
-                      <a:endParaRPr lang="en-US" sz="850" b="0">
-                        <a:solidFill>
-                          <a:schemeClr val="tx1"/>
-                        </a:solidFill>
-                        <a:effectLst/>
-                        <a:latin typeface="IBM Plex Sans Text" panose="020B0503050203000203" pitchFamily="34" charset="0"/>
-                      </a:endParaRPr>
-                    </a:p>
-                  </a:txBody>
-                  <a:tcPr marL="21880" marR="21880" marT="10940" marB="10940"/>
-                </a:tc>
-                <a:tc>
-                  <a:txBody>
-                    <a:bodyPr/>
-                    <a:lstStyle/>
-                    <a:p>
-                      <a:pPr algn="l" rtl="0" fontAlgn="t">
-                        <a:buNone/>
-                      </a:pPr>
-                      <a:r>
                         <a:rPr lang="en-US" sz="850" dirty="0">
                           <a:effectLst/>
                           <a:latin typeface="IBM Plex Sans Text" panose="020B0503050203000203" pitchFamily="34" charset="0"/>
                         </a:rPr>
-                        <a:t>Utilities</a:t>
+                        <a:t>SQL</a:t>
                       </a:r>
                       <a:endParaRPr lang="en-US" sz="850" b="0" dirty="0">
-                        <a:solidFill>
-                          <a:schemeClr val="tx1"/>
-                        </a:solidFill>
-                        <a:effectLst/>
-                        <a:latin typeface="IBM Plex Sans Text" panose="020B0503050203000203" pitchFamily="34" charset="0"/>
-                      </a:endParaRPr>
-                    </a:p>
-                  </a:txBody>
-                  <a:tcPr marL="21880" marR="21880" marT="10940" marB="10940"/>
-                </a:tc>
-                <a:tc>
-                  <a:txBody>
-                    <a:bodyPr/>
-                    <a:lstStyle/>
-                    <a:p>
-                      <a:pPr algn="l" rtl="0" fontAlgn="t">
-                        <a:buNone/>
-                      </a:pPr>
-                      <a:r>
-                        <a:rPr lang="en-US" sz="850" dirty="0">
-                          <a:effectLst/>
-                          <a:latin typeface="IBM Plex Sans Text" panose="020B0503050203000203" pitchFamily="34" charset="0"/>
-                        </a:rPr>
-                        <a:t>Copies data from one table to another.</a:t>
-                      </a:r>
-                      <a:endParaRPr lang="en-US" sz="850" b="0" dirty="0">
-                        <a:solidFill>
-                          <a:schemeClr val="tx1"/>
-                        </a:solidFill>
-                        <a:effectLst/>
-                        <a:latin typeface="IBM Plex Sans Text" panose="020B0503050203000203" pitchFamily="34" charset="0"/>
-                      </a:endParaRPr>
-                    </a:p>
-                  </a:txBody>
-                  <a:tcPr marL="21880" marR="21880" marT="10940" marB="10940"/>
-                </a:tc>
-                <a:tc>
-                  <a:txBody>
-                    <a:bodyPr/>
-                    <a:lstStyle/>
-                    <a:p>
-                      <a:pPr algn="l" rtl="0" fontAlgn="t">
-                        <a:buNone/>
-                      </a:pPr>
-                      <a:r>
-                        <a:rPr lang="en-US" sz="850">
-                          <a:effectLst/>
-                          <a:latin typeface="IBM Plex Sans Text" panose="020B0503050203000203" pitchFamily="34" charset="0"/>
-                        </a:rPr>
-                        <a:t>SQL</a:t>
-                      </a:r>
-                      <a:endParaRPr lang="en-US" sz="850" b="0">
                         <a:solidFill>
                           <a:schemeClr val="tx1"/>
                         </a:solidFill>
@@ -26767,13 +26594,6 @@
                         <a:rPr lang="en-US" sz="850" b="0" u="none" dirty="0">
                           <a:effectLst/>
                           <a:latin typeface="IBM Plex Mono Text" panose="020B0509050203000203" pitchFamily="49" charset="0"/>
-                          <a:hlinkClick r:id="rId6" tooltip="#_db2utility">
-                            <a:extLst>
-                              <a:ext uri="{A12FA001-AC4F-418D-AE19-62706E023703}">
-                                <ahyp:hlinkClr xmlns:ahyp="http://schemas.microsoft.com/office/drawing/2018/hyperlinkcolor" val="tx"/>
-                              </a:ext>
-                            </a:extLst>
-                          </a:hlinkClick>
                         </a:rPr>
                         <a:t>DB2UTILITY</a:t>
                       </a:r>
@@ -26797,13 +26617,13 @@
                         <a:buNone/>
                       </a:pPr>
                       <a:r>
-                        <a:rPr lang="en-US" sz="850">
+                        <a:rPr lang="en-US" sz="850" dirty="0">
                           <a:effectLst/>
                           <a:latin typeface="IBM Plex Sans Text" panose="020B0503050203000203" pitchFamily="34" charset="0"/>
                         </a:rPr>
                         <a:t>S</a:t>
                       </a:r>
-                      <a:endParaRPr lang="en-US" sz="850" b="0">
+                      <a:endParaRPr lang="en-US" sz="850" b="0" dirty="0">
                         <a:solidFill>
                           <a:schemeClr val="tx1"/>
                         </a:solidFill>
@@ -26908,20 +26728,13 @@
                         <a:buNone/>
                       </a:pPr>
                       <a:r>
-                        <a:rPr lang="en-US" sz="850" b="0" u="none">
+                        <a:rPr lang="en-US" sz="850" b="0" u="none" dirty="0">
                           <a:effectLst/>
                           <a:latin typeface="IBM Plex Mono Text" panose="020B0509050203000203" pitchFamily="49" charset="0"/>
-                          <a:hlinkClick r:id="rId7" tooltip="#_easter">
-                            <a:extLst>
-                              <a:ext uri="{A12FA001-AC4F-418D-AE19-62706E023703}">
-                                <ahyp:hlinkClr xmlns:ahyp="http://schemas.microsoft.com/office/drawing/2018/hyperlinkcolor" val="tx"/>
-                              </a:ext>
-                            </a:extLst>
-                          </a:hlinkClick>
                         </a:rPr>
                         <a:t>EASTER</a:t>
                       </a:r>
-                      <a:endParaRPr lang="en-US" sz="850" b="0" u="none">
+                      <a:endParaRPr lang="en-US" sz="850" b="0" u="none" dirty="0">
                         <a:solidFill>
                           <a:schemeClr val="tx1"/>
                         </a:solidFill>
@@ -27055,13 +26868,6 @@
                         <a:rPr lang="en-US" sz="850" b="0" u="none" dirty="0">
                           <a:effectLst/>
                           <a:latin typeface="IBM Plex Mono Text" panose="020B0509050203000203" pitchFamily="49" charset="0"/>
-                          <a:hlinkClick r:id="rId8" tooltip="#_formattimestamp">
-                            <a:extLst>
-                              <a:ext uri="{A12FA001-AC4F-418D-AE19-62706E023703}">
-                                <ahyp:hlinkClr xmlns:ahyp="http://schemas.microsoft.com/office/drawing/2018/hyperlinkcolor" val="tx"/>
-                              </a:ext>
-                            </a:extLst>
-                          </a:hlinkClick>
                         </a:rPr>
                         <a:t>FORMATTIMESTAMP</a:t>
                       </a:r>
@@ -27199,13 +27005,6 @@
                         <a:rPr lang="en-US" sz="850" b="0" u="none" dirty="0">
                           <a:effectLst/>
                           <a:latin typeface="IBM Plex Mono Text" panose="020B0509050203000203" pitchFamily="49" charset="0"/>
-                          <a:hlinkClick r:id="rId9" tooltip="#_generate_series">
-                            <a:extLst>
-                              <a:ext uri="{A12FA001-AC4F-418D-AE19-62706E023703}">
-                                <ahyp:hlinkClr xmlns:ahyp="http://schemas.microsoft.com/office/drawing/2018/hyperlinkcolor" val="tx"/>
-                              </a:ext>
-                            </a:extLst>
-                          </a:hlinkClick>
                         </a:rPr>
                         <a:t>GENERATE_SERIES</a:t>
                       </a:r>
@@ -27477,13 +27276,6 @@
                         <a:rPr lang="en-US" sz="850" b="0" u="none" dirty="0">
                           <a:effectLst/>
                           <a:latin typeface="IBM Plex Mono Text" panose="020B0509050203000203" pitchFamily="49" charset="0"/>
-                          <a:hlinkClick r:id="rId10" tooltip="#_hextoint">
-                            <a:extLst>
-                              <a:ext uri="{A12FA001-AC4F-418D-AE19-62706E023703}">
-                                <ahyp:hlinkClr xmlns:ahyp="http://schemas.microsoft.com/office/drawing/2018/hyperlinkcolor" val="tx"/>
-                              </a:ext>
-                            </a:extLst>
-                          </a:hlinkClick>
                         </a:rPr>
                         <a:t>HEXTOINT</a:t>
                       </a:r>
@@ -27628,27 +27420,9 @@
                           <a:ea typeface="+mn-ea"/>
                           <a:cs typeface="+mn-cs"/>
                           <a:sym typeface="IBM Plex Sans"/>
-                          <a:hlinkClick r:id="rId11" tooltip="#_racfprofile">
-                            <a:extLst>
-                              <a:ext uri="{A12FA001-AC4F-418D-AE19-62706E023703}">
-                                <ahyp:hlinkClr xmlns:ahyp="http://schemas.microsoft.com/office/drawing/2018/hyperlinkcolor" val="tx"/>
-                              </a:ext>
-                            </a:extLst>
-                          </a:hlinkClick>
                         </a:rPr>
                         <a:t>RACFPROFILE</a:t>
                       </a:r>
-                      <a:endParaRPr lang="en-US" sz="850" b="0" i="0" u="none" strike="noStrike" cap="none" spc="0" baseline="0" dirty="0">
-                        <a:solidFill>
-                          <a:schemeClr val="tx1"/>
-                        </a:solidFill>
-                        <a:effectLst/>
-                        <a:uFillTx/>
-                        <a:latin typeface="IBM Plex Mono Text" panose="020B0509050203000203" pitchFamily="49" charset="0"/>
-                        <a:ea typeface="+mn-ea"/>
-                        <a:cs typeface="+mn-cs"/>
-                        <a:sym typeface="IBM Plex Sans"/>
-                      </a:endParaRPr>
                     </a:p>
                   </a:txBody>
                   <a:tcPr marL="21880" marR="21880" marT="10940" marB="10940"/>
@@ -27773,20 +27547,13 @@
                         <a:buNone/>
                       </a:pPr>
                       <a:r>
-                        <a:rPr lang="en-US" sz="850" b="0" u="none">
+                        <a:rPr lang="en-US" sz="850" b="0" u="none" dirty="0">
                           <a:effectLst/>
                           <a:latin typeface="IBM Plex Mono Text" panose="020B0509050203000203" pitchFamily="49" charset="0"/>
-                          <a:hlinkClick r:id="rId12" tooltip="#_read_generic_file">
-                            <a:extLst>
-                              <a:ext uri="{A12FA001-AC4F-418D-AE19-62706E023703}">
-                                <ahyp:hlinkClr xmlns:ahyp="http://schemas.microsoft.com/office/drawing/2018/hyperlinkcolor" val="tx"/>
-                              </a:ext>
-                            </a:extLst>
-                          </a:hlinkClick>
                         </a:rPr>
                         <a:t>READ_GENERIC_FILE</a:t>
                       </a:r>
-                      <a:endParaRPr lang="en-US" sz="850" b="0" u="none">
+                      <a:endParaRPr lang="en-US" sz="850" b="0" u="none" dirty="0">
                         <a:solidFill>
                           <a:schemeClr val="tx1"/>
                         </a:solidFill>
@@ -27920,13 +27687,6 @@
                         <a:rPr lang="en-US" sz="850" b="0" u="none" dirty="0">
                           <a:effectLst/>
                           <a:latin typeface="IBM Plex Mono Text" panose="020B0509050203000203" pitchFamily="49" charset="0"/>
-                          <a:hlinkClick r:id="rId13" tooltip="#_regex_matches">
-                            <a:extLst>
-                              <a:ext uri="{A12FA001-AC4F-418D-AE19-62706E023703}">
-                                <ahyp:hlinkClr xmlns:ahyp="http://schemas.microsoft.com/office/drawing/2018/hyperlinkcolor" val="tx"/>
-                              </a:ext>
-                            </a:extLst>
-                          </a:hlinkClick>
                         </a:rPr>
                         <a:t>REGEX_MATCHES</a:t>
                       </a:r>
@@ -28064,13 +27824,6 @@
                         <a:rPr lang="en-US" sz="850" b="0" u="none" dirty="0">
                           <a:effectLst/>
                           <a:latin typeface="IBM Plex Mono Text" panose="020B0509050203000203" pitchFamily="49" charset="0"/>
-                          <a:hlinkClick r:id="rId14" tooltip="#_regex_replace">
-                            <a:extLst>
-                              <a:ext uri="{A12FA001-AC4F-418D-AE19-62706E023703}">
-                                <ahyp:hlinkClr xmlns:ahyp="http://schemas.microsoft.com/office/drawing/2018/hyperlinkcolor" val="tx"/>
-                              </a:ext>
-                            </a:extLst>
-                          </a:hlinkClick>
                         </a:rPr>
                         <a:t>REGEX_REPLACE</a:t>
                       </a:r>
@@ -28208,13 +27961,6 @@
                         <a:rPr lang="en-US" sz="850" b="0" u="none" dirty="0">
                           <a:effectLst/>
                           <a:latin typeface="IBM Plex Mono Text" panose="020B0509050203000203" pitchFamily="49" charset="0"/>
-                          <a:hlinkClick r:id="rId15" tooltip="#_runstats">
-                            <a:extLst>
-                              <a:ext uri="{A12FA001-AC4F-418D-AE19-62706E023703}">
-                                <ahyp:hlinkClr xmlns:ahyp="http://schemas.microsoft.com/office/drawing/2018/hyperlinkcolor" val="tx"/>
-                              </a:ext>
-                            </a:extLst>
-                          </a:hlinkClick>
                         </a:rPr>
                         <a:t>RUNSTATS</a:t>
                       </a:r>
@@ -28352,13 +28098,6 @@
                         <a:rPr lang="en-US" sz="850" b="0" u="none" dirty="0">
                           <a:effectLst/>
                           <a:latin typeface="IBM Plex Mono Text" panose="020B0509050203000203" pitchFamily="49" charset="0"/>
-                          <a:hlinkClick r:id="rId16" tooltip="#_split">
-                            <a:extLst>
-                              <a:ext uri="{A12FA001-AC4F-418D-AE19-62706E023703}">
-                                <ahyp:hlinkClr xmlns:ahyp="http://schemas.microsoft.com/office/drawing/2018/hyperlinkcolor" val="tx"/>
-                              </a:ext>
-                            </a:extLst>
-                          </a:hlinkClick>
                         </a:rPr>
                         <a:t>SPLIT</a:t>
                       </a:r>
@@ -28496,13 +28235,6 @@
                         <a:rPr lang="en-US" sz="850" b="0" u="none" dirty="0">
                           <a:effectLst/>
                           <a:latin typeface="IBM Plex Mono Text" panose="020B0509050203000203" pitchFamily="49" charset="0"/>
-                          <a:hlinkClick r:id="rId17" tooltip="#_sprintf">
-                            <a:extLst>
-                              <a:ext uri="{A12FA001-AC4F-418D-AE19-62706E023703}">
-                                <ahyp:hlinkClr xmlns:ahyp="http://schemas.microsoft.com/office/drawing/2018/hyperlinkcolor" val="tx"/>
-                              </a:ext>
-                            </a:extLst>
-                          </a:hlinkClick>
                         </a:rPr>
                         <a:t>SPRINTF</a:t>
                       </a:r>
@@ -28640,13 +28372,6 @@
                         <a:rPr lang="en-US" sz="850" b="0" u="none" dirty="0">
                           <a:effectLst/>
                           <a:latin typeface="IBM Plex Mono Text" panose="020B0509050203000203" pitchFamily="49" charset="0"/>
-                          <a:hlinkClick r:id="rId18" tooltip="#:submit">
-                            <a:extLst>
-                              <a:ext uri="{A12FA001-AC4F-418D-AE19-62706E023703}">
-                                <ahyp:hlinkClr xmlns:ahyp="http://schemas.microsoft.com/office/drawing/2018/hyperlinkcolor" val="tx"/>
-                              </a:ext>
-                            </a:extLst>
-                          </a:hlinkClick>
                         </a:rPr>
                         <a:t>SUBMIT</a:t>
                       </a:r>
@@ -28784,13 +28509,6 @@
                         <a:rPr lang="en-US" sz="850" b="0" u="none" dirty="0">
                           <a:effectLst/>
                           <a:latin typeface="IBM Plex Mono Text" panose="020B0509050203000203" pitchFamily="49" charset="0"/>
-                          <a:hlinkClick r:id="rId18" tooltip="#:submit">
-                            <a:extLst>
-                              <a:ext uri="{A12FA001-AC4F-418D-AE19-62706E023703}">
-                                <ahyp:hlinkClr xmlns:ahyp="http://schemas.microsoft.com/office/drawing/2018/hyperlinkcolor" val="tx"/>
-                              </a:ext>
-                            </a:extLst>
-                          </a:hlinkClick>
                         </a:rPr>
                         <a:t>SUBMIT_T</a:t>
                       </a:r>
@@ -28928,13 +28646,6 @@
                         <a:rPr lang="en-US" sz="850" b="0" u="none" dirty="0">
                           <a:effectLst/>
                           <a:latin typeface="IBM Plex Mono Text" panose="020B0509050203000203" pitchFamily="49" charset="0"/>
-                          <a:hlinkClick r:id="rId19" tooltip="#_to_roman">
-                            <a:extLst>
-                              <a:ext uri="{A12FA001-AC4F-418D-AE19-62706E023703}">
-                                <ahyp:hlinkClr xmlns:ahyp="http://schemas.microsoft.com/office/drawing/2018/hyperlinkcolor" val="tx"/>
-                              </a:ext>
-                            </a:extLst>
-                          </a:hlinkClick>
                         </a:rPr>
                         <a:t>TO_ROMAN</a:t>
                       </a:r>
@@ -29072,42 +28783,8 @@
                         <a:rPr lang="en-US" sz="850" b="0" u="none" dirty="0">
                           <a:effectLst/>
                           <a:latin typeface="IBM Plex Mono Text" panose="020B0509050203000203" pitchFamily="49" charset="0"/>
-                          <a:hlinkClick r:id="rId20" tooltip="#:try_integer">
-                            <a:extLst>
-                              <a:ext uri="{A12FA001-AC4F-418D-AE19-62706E023703}">
-                                <ahyp:hlinkClr xmlns:ahyp="http://schemas.microsoft.com/office/drawing/2018/hyperlinkcolor" val="tx"/>
-                              </a:ext>
-                            </a:extLst>
-                          </a:hlinkClick>
-                        </a:rPr>
-                        <a:t>TRY_INTEGER, TRY_SMALLINT,</a:t>
-                      </a:r>
-                      <a:br>
-                        <a:rPr lang="en-US" sz="850" b="0" u="none" dirty="0">
-                          <a:effectLst/>
-                          <a:latin typeface="IBM Plex Mono Text" panose="020B0509050203000203" pitchFamily="49" charset="0"/>
-                          <a:hlinkClick r:id="rId20" tooltip="#:try_integer">
-                            <a:extLst>
-                              <a:ext uri="{A12FA001-AC4F-418D-AE19-62706E023703}">
-                                <ahyp:hlinkClr xmlns:ahyp="http://schemas.microsoft.com/office/drawing/2018/hyperlinkcolor" val="tx"/>
-                              </a:ext>
-                            </a:extLst>
-                          </a:hlinkClick>
-                        </a:rPr>
-                      </a:br>
-                      <a:r>
-                        <a:rPr lang="en-US" sz="850" b="0" u="none" dirty="0">
-                          <a:effectLst/>
-                          <a:latin typeface="IBM Plex Mono Text" panose="020B0509050203000203" pitchFamily="49" charset="0"/>
-                          <a:hlinkClick r:id="rId20" tooltip="#:try_integer">
-                            <a:extLst>
-                              <a:ext uri="{A12FA001-AC4F-418D-AE19-62706E023703}">
-                                <ahyp:hlinkClr xmlns:ahyp="http://schemas.microsoft.com/office/drawing/2018/hyperlinkcolor" val="tx"/>
-                              </a:ext>
-                            </a:extLst>
-                          </a:hlinkClick>
-                        </a:rPr>
-                        <a:t>TRY_BIGINT</a:t>
+                        </a:rPr>
+                        <a:t>TRY_INTEGER, …</a:t>
                       </a:r>
                       <a:endParaRPr lang="en-US" sz="850" b="0" u="none" dirty="0">
                         <a:solidFill>
@@ -29243,13 +28920,6 @@
                         <a:rPr lang="en-US" sz="850" b="0" u="none" dirty="0">
                           <a:effectLst/>
                           <a:latin typeface="IBM Plex Mono Text" panose="020B0509050203000203" pitchFamily="49" charset="0"/>
-                          <a:hlinkClick r:id="rId21" tooltip="#_validate_conversion">
-                            <a:extLst>
-                              <a:ext uri="{A12FA001-AC4F-418D-AE19-62706E023703}">
-                                <ahyp:hlinkClr xmlns:ahyp="http://schemas.microsoft.com/office/drawing/2018/hyperlinkcolor" val="tx"/>
-                              </a:ext>
-                            </a:extLst>
-                          </a:hlinkClick>
                         </a:rPr>
                         <a:t>VALIDATE_CONVERSION</a:t>
                       </a:r>
@@ -31869,7 +31539,7 @@
                         <a:buNone/>
                       </a:pPr>
                       <a:r>
-                        <a:rPr sz="1400" b="1">
+                        <a:rPr sz="1400" b="1" dirty="0">
                           <a:solidFill>
                             <a:schemeClr val="tx1"/>
                           </a:solidFill>

</xml_diff>